<commit_message>
feat: add plan-aware AI provisioning and usage metering
</commit_message>
<xml_diff>
--- a/assets/onboarding/Opturon_Primeros_Pasos_Cliente.pptx
+++ b/assets/onboarding/Opturon_Primeros_Pasos_Cliente.pptx
@@ -2,22 +2,23 @@
 <file path=ppt/presentation.xml><?xml version="1.0" encoding="utf-8"?>
 <p:presentation xmlns:p="http://schemas.openxmlformats.org/presentationml/2006/main">
   <p:sldMasterIdLst>
-    <p:sldMasterId xmlns:r="http://schemas.openxmlformats.org/officeDocument/2006/relationships" id="2147483648" r:id="R450bcee3038a4e7b"/>
+    <p:sldMasterId xmlns:r="http://schemas.openxmlformats.org/officeDocument/2006/relationships" id="2147483648" r:id="R4be95e0019244102"/>
   </p:sldMasterIdLst>
   <p:notesMasterIdLst>
-    <p:notesMasterId xmlns:r="http://schemas.openxmlformats.org/officeDocument/2006/relationships" r:id="Rf0d188e42b7c40b7"/>
+    <p:notesMasterId xmlns:r="http://schemas.openxmlformats.org/officeDocument/2006/relationships" r:id="R26489a2ed1f64fec"/>
   </p:notesMasterIdLst>
   <p:sldIdLst>
-    <p:sldId xmlns:r="http://schemas.openxmlformats.org/officeDocument/2006/relationships" id="256" r:id="R2d83c930425f423d"/>
-    <p:sldId xmlns:r="http://schemas.openxmlformats.org/officeDocument/2006/relationships" id="257" r:id="R47763c49bc7d44bf"/>
-    <p:sldId xmlns:r="http://schemas.openxmlformats.org/officeDocument/2006/relationships" id="258" r:id="R071dd1674adc4e0f"/>
-    <p:sldId xmlns:r="http://schemas.openxmlformats.org/officeDocument/2006/relationships" id="259" r:id="R43eeebcce2534876"/>
-    <p:sldId xmlns:r="http://schemas.openxmlformats.org/officeDocument/2006/relationships" id="260" r:id="R636542fb5c324c6c"/>
-    <p:sldId xmlns:r="http://schemas.openxmlformats.org/officeDocument/2006/relationships" id="261" r:id="Rf443b6af90754621"/>
-    <p:sldId xmlns:r="http://schemas.openxmlformats.org/officeDocument/2006/relationships" id="262" r:id="R18ee876c7f6a4f21"/>
-    <p:sldId xmlns:r="http://schemas.openxmlformats.org/officeDocument/2006/relationships" id="263" r:id="Rb7ef268517664bad"/>
-    <p:sldId xmlns:r="http://schemas.openxmlformats.org/officeDocument/2006/relationships" id="264" r:id="R43598729363c4520"/>
-    <p:sldId xmlns:r="http://schemas.openxmlformats.org/officeDocument/2006/relationships" id="265" r:id="R560fe47e94124977"/>
+    <p:sldId xmlns:r="http://schemas.openxmlformats.org/officeDocument/2006/relationships" id="256" r:id="Rd77b7f4da9bf453d"/>
+    <p:sldId xmlns:r="http://schemas.openxmlformats.org/officeDocument/2006/relationships" id="257" r:id="R742277d0abfb44c1"/>
+    <p:sldId xmlns:r="http://schemas.openxmlformats.org/officeDocument/2006/relationships" id="258" r:id="R17c3ddf9d08f4565"/>
+    <p:sldId xmlns:r="http://schemas.openxmlformats.org/officeDocument/2006/relationships" id="259" r:id="Rc6eda4472a8145f5"/>
+    <p:sldId xmlns:r="http://schemas.openxmlformats.org/officeDocument/2006/relationships" id="260" r:id="R9583822c4e00427e"/>
+    <p:sldId xmlns:r="http://schemas.openxmlformats.org/officeDocument/2006/relationships" id="261" r:id="Rbb9e1521fd6241eb"/>
+    <p:sldId xmlns:r="http://schemas.openxmlformats.org/officeDocument/2006/relationships" id="262" r:id="R6c217b2bb67d48af"/>
+    <p:sldId xmlns:r="http://schemas.openxmlformats.org/officeDocument/2006/relationships" id="263" r:id="R6e26041783f34867"/>
+    <p:sldId xmlns:r="http://schemas.openxmlformats.org/officeDocument/2006/relationships" id="264" r:id="Rcc39bc74ea6b4fd5"/>
+    <p:sldId xmlns:r="http://schemas.openxmlformats.org/officeDocument/2006/relationships" id="265" r:id="R1b4f4130aebb4866"/>
+    <p:sldId xmlns:r="http://schemas.openxmlformats.org/officeDocument/2006/relationships" id="266" r:id="Rde340155f02e47ad"/>
   </p:sldIdLst>
   <p:sldSz cx="12192000" cy="6858000"/>
   <p:notesSz cx="6858000" cy="9144000"/>
@@ -551,6 +552,76 @@
 </p:notes>
 </file>
 
+<file path=ppt/notesSlides/notesSlide11.xml><?xml version="1.0" encoding="utf-8"?>
+<p:notes xmlns:p="http://schemas.openxmlformats.org/presentationml/2006/main">
+  <p:cSld>
+    <p:spTree>
+      <p:nvGrpSpPr>
+        <p:cNvPr id="1" name=""/>
+        <p:cNvGrpSpPr/>
+        <p:nvPr/>
+      </p:nvGrpSpPr>
+      <p:grpSpPr>
+        <a:xfrm xmlns:a="http://schemas.openxmlformats.org/drawingml/2006/main"/>
+      </p:grpSpPr>
+      <p:sp>
+        <p:nvSpPr>
+          <p:cNvPr id="2" name="Slide Image Placeholder 1"/>
+          <p:cNvSpPr>
+            <a:spLocks xmlns:a="http://schemas.openxmlformats.org/drawingml/2006/main" noGrp="1"/>
+          </p:cNvSpPr>
+          <p:nvPr>
+            <p:ph type="sldImg" idx="0"/>
+          </p:nvPr>
+        </p:nvSpPr>
+        <p:spPr/>
+      </p:sp>
+      <p:sp>
+        <p:nvSpPr>
+          <p:cNvPr id="3" name="Notes Placeholder 2"/>
+          <p:cNvSpPr>
+            <a:spLocks xmlns:a="http://schemas.openxmlformats.org/drawingml/2006/main" noGrp="1"/>
+          </p:cNvSpPr>
+          <p:nvPr>
+            <p:ph type="body" idx="1"/>
+          </p:nvPr>
+        </p:nvSpPr>
+        <p:spPr/>
+        <p:txBody>
+          <a:bodyPr xmlns:a="http://schemas.openxmlformats.org/drawingml/2006/main"/>
+          <a:lstStyle xmlns:a="http://schemas.openxmlformats.org/drawingml/2006/main"/>
+          <a:p xmlns:a="http://schemas.openxmlformats.org/drawingml/2006/main">
+            <a:r>
+              <a:t>Contenido institucional de Opturon. Información general, sujeta al plan o a las reglas vigentes del Portal del Asesor.</a:t>
+            </a:r>
+          </a:p>
+        </p:txBody>
+      </p:sp>
+      <p:sp>
+        <p:nvSpPr>
+          <p:cNvPr id="4" name="Slide Number Placeholder 3"/>
+          <p:cNvSpPr>
+            <a:spLocks xmlns:a="http://schemas.openxmlformats.org/drawingml/2006/main" noGrp="1"/>
+          </p:cNvSpPr>
+          <p:nvPr>
+            <p:ph type="sldNum" idx="5"/>
+          </p:nvPr>
+        </p:nvSpPr>
+        <p:spPr/>
+        <p:txBody>
+          <a:bodyPr xmlns:a="http://schemas.openxmlformats.org/drawingml/2006/main"/>
+          <a:lstStyle xmlns:a="http://schemas.openxmlformats.org/drawingml/2006/main"/>
+          <a:p xmlns:a="http://schemas.openxmlformats.org/drawingml/2006/main"/>
+        </p:txBody>
+      </p:sp>
+    </p:spTree>
+  </p:cSld>
+  <p:clrMapOvr>
+    <a:masterClrMapping xmlns:a="http://schemas.openxmlformats.org/drawingml/2006/main"/>
+  </p:clrMapOvr>
+</p:notes>
+</file>
+
 <file path=ppt/notesSlides/notesSlide2.xml><?xml version="1.0" encoding="utf-8"?>
 <p:notes xmlns:p="http://schemas.openxmlformats.org/presentationml/2006/main">
   <p:cSld>
@@ -1149,7 +1220,7 @@
   </p:cSld>
   <p:clrMap bg1="lt1" tx1="dk1" bg2="lt2" tx2="dk2" accent1="accent1" accent2="accent2" accent3="accent3" accent4="accent4" accent5="accent5" accent6="accent6" hlink="hlink" folHlink="folHlink"/>
   <p:sldLayoutIdLst>
-    <p:sldLayoutId xmlns:r="http://schemas.openxmlformats.org/officeDocument/2006/relationships" id="2147483649" r:id="R6426fcf8533a4c2b"/>
+    <p:sldLayoutId xmlns:r="http://schemas.openxmlformats.org/officeDocument/2006/relationships" id="2147483649" r:id="R14af38c6423347c0"/>
   </p:sldLayoutIdLst>
   <p:txStyles>
     <p:titleStyle>
@@ -1700,7 +1771,7 @@
           <p:cNvPr id="8" name="">
             <a:extLst xmlns:a="http://schemas.openxmlformats.org/drawingml/2006/main">
               <a:ext uri="{FF2B5EF4-FFF2-40B4-BE49-F238E27FC236}">
-                <a16:creationId xmlns:a16="http://schemas.microsoft.com/office/drawing/2014/main" id="{F3096446-9363-4AFB-81AD-F85E9685A145}"/>
+                <a16:creationId xmlns:a16="http://schemas.microsoft.com/office/drawing/2014/main" id="{6914B430-A95A-41A0-84CC-B7850BAC81DB}"/>
               </a:ext>
             </a:extLst>
           </p:cNvPr>
@@ -1757,7 +1828,7 @@
           <p:cNvPr id="2" name="">
             <a:extLst xmlns:a="http://schemas.openxmlformats.org/drawingml/2006/main">
               <a:ext uri="{FF2B5EF4-FFF2-40B4-BE49-F238E27FC236}">
-                <a16:creationId xmlns:a16="http://schemas.microsoft.com/office/drawing/2014/main" id="{BC5082A5-36B5-4905-8646-02B83081EB04}"/>
+                <a16:creationId xmlns:a16="http://schemas.microsoft.com/office/drawing/2014/main" id="{0B52F016-3185-498C-8816-FB3CF791D789}"/>
               </a:ext>
             </a:extLst>
           </p:cNvPr>
@@ -1814,7 +1885,7 @@
           <p:cNvPr id="3" name="">
             <a:extLst xmlns:a="http://schemas.openxmlformats.org/drawingml/2006/main">
               <a:ext uri="{FF2B5EF4-FFF2-40B4-BE49-F238E27FC236}">
-                <a16:creationId xmlns:a16="http://schemas.microsoft.com/office/drawing/2014/main" id="{4E48D0D4-6521-4395-B375-359892F53573}"/>
+                <a16:creationId xmlns:a16="http://schemas.microsoft.com/office/drawing/2014/main" id="{FB763E31-9393-40C5-BA23-79D146B6CA2C}"/>
               </a:ext>
             </a:extLst>
           </p:cNvPr>
@@ -1871,7 +1942,7 @@
           <p:cNvPr id="4" name="">
             <a:extLst xmlns:a="http://schemas.openxmlformats.org/drawingml/2006/main">
               <a:ext uri="{FF2B5EF4-FFF2-40B4-BE49-F238E27FC236}">
-                <a16:creationId xmlns:a16="http://schemas.microsoft.com/office/drawing/2014/main" id="{ED8C3EAF-F744-4BBF-9F42-9A9E45FA0853}"/>
+                <a16:creationId xmlns:a16="http://schemas.microsoft.com/office/drawing/2014/main" id="{F07FD1EC-9F62-45E9-AB75-325074AAE278}"/>
               </a:ext>
             </a:extLst>
           </p:cNvPr>
@@ -1928,7 +1999,7 @@
           <p:cNvPr id="5" name="">
             <a:extLst xmlns:a="http://schemas.openxmlformats.org/drawingml/2006/main">
               <a:ext uri="{FF2B5EF4-FFF2-40B4-BE49-F238E27FC236}">
-                <a16:creationId xmlns:a16="http://schemas.microsoft.com/office/drawing/2014/main" id="{2814BC3F-6D87-46D2-9126-295E1A2491F7}"/>
+                <a16:creationId xmlns:a16="http://schemas.microsoft.com/office/drawing/2014/main" id="{B98B7E20-12A4-45B5-A7A7-50B022E80BB1}"/>
               </a:ext>
             </a:extLst>
           </p:cNvPr>
@@ -1985,7 +2056,7 @@
           <p:cNvPr id="6" name="">
             <a:extLst xmlns:a="http://schemas.openxmlformats.org/drawingml/2006/main">
               <a:ext uri="{FF2B5EF4-FFF2-40B4-BE49-F238E27FC236}">
-                <a16:creationId xmlns:a16="http://schemas.microsoft.com/office/drawing/2014/main" id="{51223813-BC19-4B4B-AD26-388D183FA40D}"/>
+                <a16:creationId xmlns:a16="http://schemas.microsoft.com/office/drawing/2014/main" id="{11E3C051-63C3-46BD-B2A8-D25402604DD8}"/>
               </a:ext>
             </a:extLst>
           </p:cNvPr>
@@ -2042,7 +2113,7 @@
           <p:cNvPr id="7" name="">
             <a:extLst xmlns:a="http://schemas.openxmlformats.org/drawingml/2006/main">
               <a:ext uri="{FF2B5EF4-FFF2-40B4-BE49-F238E27FC236}">
-                <a16:creationId xmlns:a16="http://schemas.microsoft.com/office/drawing/2014/main" id="{061B7733-FD5C-4C07-90AC-12BF5E299422}"/>
+                <a16:creationId xmlns:a16="http://schemas.microsoft.com/office/drawing/2014/main" id="{CCFFB4D8-9E76-4399-9115-D9A3B6E48D49}"/>
               </a:ext>
             </a:extLst>
           </p:cNvPr>
@@ -2097,7 +2168,7 @@
     </p:spTree>
     <p:extLst>
       <p:ext uri="{BB962C8B-B14F-4D97-AF65-F5344CB8AC3E}">
-        <p14:creationId xmlns:p14="http://schemas.microsoft.com/office/powerpoint/2010/main" val="82126305"/>
+        <p14:creationId xmlns:p14="http://schemas.microsoft.com/office/powerpoint/2010/main" val="285952527"/>
       </p:ext>
     </p:extLst>
   </p:cSld>
@@ -2125,10 +2196,10 @@
       </p:grpSpPr>
       <p:sp>
         <p:nvSpPr>
-          <p:cNvPr id="9" name="">
-            <a:extLst xmlns:a="http://schemas.openxmlformats.org/drawingml/2006/main">
-              <a:ext uri="{FF2B5EF4-FFF2-40B4-BE49-F238E27FC236}">
-                <a16:creationId xmlns:a16="http://schemas.microsoft.com/office/drawing/2014/main" id="{C42A40A2-9B1C-4DD3-BF2B-4CA2FAF703B5}"/>
+          <p:cNvPr id="7" name="">
+            <a:extLst xmlns:a="http://schemas.openxmlformats.org/drawingml/2006/main">
+              <a:ext uri="{FF2B5EF4-FFF2-40B4-BE49-F238E27FC236}">
+                <a16:creationId xmlns:a16="http://schemas.microsoft.com/office/drawing/2014/main" id="{2B8AA318-914F-4447-AC6F-A011EA375059}"/>
               </a:ext>
             </a:extLst>
           </p:cNvPr>
@@ -2185,7 +2256,7 @@
           <p:cNvPr id="2" name="">
             <a:extLst xmlns:a="http://schemas.openxmlformats.org/drawingml/2006/main">
               <a:ext uri="{FF2B5EF4-FFF2-40B4-BE49-F238E27FC236}">
-                <a16:creationId xmlns:a16="http://schemas.microsoft.com/office/drawing/2014/main" id="{71C1603C-0D66-43B4-97F8-11276E3A35BF}"/>
+                <a16:creationId xmlns:a16="http://schemas.microsoft.com/office/drawing/2014/main" id="{83F49242-8916-469C-957A-DECCA7428BF7}"/>
               </a:ext>
             </a:extLst>
           </p:cNvPr>
@@ -2232,7 +2303,7 @@
                 <a:ea typeface="Arial"/>
                 <a:cs typeface="Arial"/>
               </a:rPr>
-              <a:t>PRÓXIMOS PASOS</a:t>
+              <a:t>AUTOMATIZACIÓN</a:t>
             </a:r>
           </a:p>
         </p:txBody>
@@ -2242,7 +2313,7 @@
           <p:cNvPr id="3" name="">
             <a:extLst xmlns:a="http://schemas.openxmlformats.org/drawingml/2006/main">
               <a:ext uri="{FF2B5EF4-FFF2-40B4-BE49-F238E27FC236}">
-                <a16:creationId xmlns:a16="http://schemas.microsoft.com/office/drawing/2014/main" id="{F7BAC0F2-73CB-4194-8379-38A5AF8543AB}"/>
+                <a16:creationId xmlns:a16="http://schemas.microsoft.com/office/drawing/2014/main" id="{CA6E8D0D-6469-4682-9CB0-95BCDF1B971A}"/>
               </a:ext>
             </a:extLst>
           </p:cNvPr>
@@ -2289,7 +2360,7 @@
                 <a:ea typeface="Arial"/>
                 <a:cs typeface="Arial"/>
               </a:rPr>
-              <a:t>Empezá con claridad</a:t>
+              <a:t>Automatizaciones y asistente</a:t>
             </a:r>
           </a:p>
         </p:txBody>
@@ -2299,7 +2370,7 @@
           <p:cNvPr id="4" name="">
             <a:extLst xmlns:a="http://schemas.openxmlformats.org/drawingml/2006/main">
               <a:ext uri="{FF2B5EF4-FFF2-40B4-BE49-F238E27FC236}">
-                <a16:creationId xmlns:a16="http://schemas.microsoft.com/office/drawing/2014/main" id="{AB45F3B0-433F-4CBC-B5FC-07701A3CC418}"/>
+                <a16:creationId xmlns:a16="http://schemas.microsoft.com/office/drawing/2014/main" id="{F73E47EF-6B50-4671-9084-81E41E1B7455}"/>
               </a:ext>
             </a:extLst>
           </p:cNvPr>
@@ -2346,7 +2417,7 @@
                 <a:ea typeface="Arial"/>
                 <a:cs typeface="Arial"/>
               </a:rPr>
-              <a:t>Si todavía no activaste</a:t>
+              <a:t>Capacidades</a:t>
             </a:r>
           </a:p>
         </p:txBody>
@@ -2356,7 +2427,7 @@
           <p:cNvPr id="5" name="">
             <a:extLst xmlns:a="http://schemas.openxmlformats.org/drawingml/2006/main">
               <a:ext uri="{FF2B5EF4-FFF2-40B4-BE49-F238E27FC236}">
-                <a16:creationId xmlns:a16="http://schemas.microsoft.com/office/drawing/2014/main" id="{AB1EFF11-0042-43FA-9B42-279439FF5285}"/>
+                <a16:creationId xmlns:a16="http://schemas.microsoft.com/office/drawing/2014/main" id="{4B58551E-1BB2-4861-B9C4-6793A1D95F8B}"/>
               </a:ext>
             </a:extLst>
           </p:cNvPr>
@@ -2403,7 +2474,7 @@
                 <a:ea typeface="Arial"/>
                 <a:cs typeface="Arial"/>
               </a:rPr>
-              <a:t>Volvé a la contratación desde tu cuenta y completá la autorización.</a:t>
+              <a:t>Las automatizaciones y el asistente disponibles dependen del plan contratado.</a:t>
             </a:r>
           </a:p>
         </p:txBody>
@@ -2413,121 +2484,7 @@
           <p:cNvPr id="6" name="">
             <a:extLst xmlns:a="http://schemas.openxmlformats.org/drawingml/2006/main">
               <a:ext uri="{FF2B5EF4-FFF2-40B4-BE49-F238E27FC236}">
-                <a16:creationId xmlns:a16="http://schemas.microsoft.com/office/drawing/2014/main" id="{72B39B70-D4B5-4A2F-9063-2522E3DFB602}"/>
-              </a:ext>
-            </a:extLst>
-          </p:cNvPr>
-          <p:cNvSpPr>
-            <a:spLocks xmlns:a="http://schemas.openxmlformats.org/drawingml/2006/main" noGrp="1"/>
-          </p:cNvSpPr>
-          <p:nvPr/>
-        </p:nvSpPr>
-        <p:spPr>
-          <a:xfrm xmlns:a="http://schemas.openxmlformats.org/drawingml/2006/main">
-            <a:off x="819150" y="3543300"/>
-            <a:ext cx="3429000" cy="285750"/>
-          </a:xfrm>
-          <a:prstGeom xmlns:a="http://schemas.openxmlformats.org/drawingml/2006/main" prst="rect">
-            <a:avLst/>
-          </a:prstGeom>
-          <a:noFill xmlns:a="http://schemas.openxmlformats.org/drawingml/2006/main"/>
-          <a:ln xmlns:a="http://schemas.openxmlformats.org/drawingml/2006/main" w="0">
-            <a:noFill/>
-          </a:ln>
-        </p:spPr>
-        <p:txBody>
-          <a:bodyPr xmlns:a="http://schemas.openxmlformats.org/drawingml/2006/main">
-            <a:normAutofit fontScale="89474"/>
-          </a:bodyPr>
-          <a:lstStyle xmlns:a="http://schemas.openxmlformats.org/drawingml/2006/main"/>
-          <a:p xmlns:a="http://schemas.openxmlformats.org/drawingml/2006/main">
-            <a:pPr>
-              <a:defRPr sz="1425" b="1">
-                <a:solidFill>
-                  <a:srgbClr val="73C9FF"/>
-                </a:solidFill>
-                <a:latin typeface="Arial"/>
-                <a:ea typeface="Arial"/>
-                <a:cs typeface="Arial"/>
-              </a:defRPr>
-            </a:pPr>
-            <a:r>
-              <a:rPr sz="1425" b="1">
-                <a:solidFill>
-                  <a:srgbClr val="73C9FF"/>
-                </a:solidFill>
-                <a:latin typeface="Arial"/>
-                <a:ea typeface="Arial"/>
-                <a:cs typeface="Arial"/>
-              </a:rPr>
-              <a:t>Soporte</a:t>
-            </a:r>
-          </a:p>
-        </p:txBody>
-      </p:sp>
-      <p:sp>
-        <p:nvSpPr>
-          <p:cNvPr id="7" name="">
-            <a:extLst xmlns:a="http://schemas.openxmlformats.org/drawingml/2006/main">
-              <a:ext uri="{FF2B5EF4-FFF2-40B4-BE49-F238E27FC236}">
-                <a16:creationId xmlns:a16="http://schemas.microsoft.com/office/drawing/2014/main" id="{8A975308-32D9-4DED-8A68-5D66EC57EDD3}"/>
-              </a:ext>
-            </a:extLst>
-          </p:cNvPr>
-          <p:cNvSpPr>
-            <a:spLocks xmlns:a="http://schemas.openxmlformats.org/drawingml/2006/main" noGrp="1"/>
-          </p:cNvSpPr>
-          <p:nvPr/>
-        </p:nvSpPr>
-        <p:spPr>
-          <a:xfrm xmlns:a="http://schemas.openxmlformats.org/drawingml/2006/main">
-            <a:off x="4476750" y="3543300"/>
-            <a:ext cx="6667500" cy="533400"/>
-          </a:xfrm>
-          <a:prstGeom xmlns:a="http://schemas.openxmlformats.org/drawingml/2006/main" prst="rect">
-            <a:avLst/>
-          </a:prstGeom>
-          <a:noFill xmlns:a="http://schemas.openxmlformats.org/drawingml/2006/main"/>
-          <a:ln xmlns:a="http://schemas.openxmlformats.org/drawingml/2006/main" w="0">
-            <a:noFill/>
-          </a:ln>
-        </p:spPr>
-        <p:txBody>
-          <a:bodyPr xmlns:a="http://schemas.openxmlformats.org/drawingml/2006/main">
-            <a:normAutofit fontScale="100000"/>
-          </a:bodyPr>
-          <a:lstStyle xmlns:a="http://schemas.openxmlformats.org/drawingml/2006/main"/>
-          <a:p xmlns:a="http://schemas.openxmlformats.org/drawingml/2006/main">
-            <a:pPr>
-              <a:defRPr sz="1425" b="0">
-                <a:solidFill>
-                  <a:srgbClr val="DCE8F6"/>
-                </a:solidFill>
-                <a:latin typeface="Arial"/>
-                <a:ea typeface="Arial"/>
-                <a:cs typeface="Arial"/>
-              </a:defRPr>
-            </a:pPr>
-            <a:r>
-              <a:rPr sz="1425" b="0">
-                <a:solidFill>
-                  <a:srgbClr val="DCE8F6"/>
-                </a:solidFill>
-                <a:latin typeface="Arial"/>
-                <a:ea typeface="Arial"/>
-                <a:cs typeface="Arial"/>
-              </a:rPr>
-              <a:t>Si necesitás ayuda, usá el canal de contacto de Opturon.</a:t>
-            </a:r>
-          </a:p>
-        </p:txBody>
-      </p:sp>
-      <p:sp>
-        <p:nvSpPr>
-          <p:cNvPr id="8" name="">
-            <a:extLst xmlns:a="http://schemas.openxmlformats.org/drawingml/2006/main">
-              <a:ext uri="{FF2B5EF4-FFF2-40B4-BE49-F238E27FC236}">
-                <a16:creationId xmlns:a16="http://schemas.microsoft.com/office/drawing/2014/main" id="{566F2EDA-BF26-4529-AC83-DF7E92357227}"/>
+                <a16:creationId xmlns:a16="http://schemas.microsoft.com/office/drawing/2014/main" id="{45FCE6AD-B814-44C4-8397-A04739413399}"/>
               </a:ext>
             </a:extLst>
           </p:cNvPr>
@@ -2582,7 +2539,492 @@
     </p:spTree>
     <p:extLst>
       <p:ext uri="{BB962C8B-B14F-4D97-AF65-F5344CB8AC3E}">
-        <p14:creationId xmlns:p14="http://schemas.microsoft.com/office/powerpoint/2010/main" val="1105119421"/>
+        <p14:creationId xmlns:p14="http://schemas.microsoft.com/office/powerpoint/2010/main" val="1860912116"/>
+      </p:ext>
+    </p:extLst>
+  </p:cSld>
+</p:sld>
+</file>
+
+<file path=ppt/slides/slide11.xml><?xml version="1.0" encoding="utf-8"?>
+<p:sld xmlns:p="http://schemas.openxmlformats.org/presentationml/2006/main">
+  <p:cSld>
+    <p:bg>
+      <p:bgPr>
+        <a:solidFill xmlns:a="http://schemas.openxmlformats.org/drawingml/2006/main">
+          <a:srgbClr val="081827"/>
+        </a:solidFill>
+      </p:bgPr>
+    </p:bg>
+    <p:spTree>
+      <p:nvGrpSpPr>
+        <p:cNvPr id="1" name=""/>
+        <p:cNvGrpSpPr/>
+        <p:nvPr/>
+      </p:nvGrpSpPr>
+      <p:grpSpPr>
+        <a:xfrm xmlns:a="http://schemas.openxmlformats.org/drawingml/2006/main"/>
+      </p:grpSpPr>
+      <p:sp>
+        <p:nvSpPr>
+          <p:cNvPr id="9" name="">
+            <a:extLst xmlns:a="http://schemas.openxmlformats.org/drawingml/2006/main">
+              <a:ext uri="{FF2B5EF4-FFF2-40B4-BE49-F238E27FC236}">
+                <a16:creationId xmlns:a16="http://schemas.microsoft.com/office/drawing/2014/main" id="{93EA5F4A-D6DE-40DF-88B7-6121DF5CA6A7}"/>
+              </a:ext>
+            </a:extLst>
+          </p:cNvPr>
+          <p:cNvSpPr>
+            <a:spLocks xmlns:a="http://schemas.openxmlformats.org/drawingml/2006/main" noGrp="1"/>
+          </p:cNvSpPr>
+          <p:nvPr/>
+        </p:nvSpPr>
+        <p:spPr>
+          <a:xfrm xmlns:a="http://schemas.openxmlformats.org/drawingml/2006/main">
+            <a:off x="685800" y="457200"/>
+            <a:ext cx="1714500" cy="266700"/>
+          </a:xfrm>
+          <a:prstGeom xmlns:a="http://schemas.openxmlformats.org/drawingml/2006/main" prst="rect">
+            <a:avLst/>
+          </a:prstGeom>
+          <a:noFill xmlns:a="http://schemas.openxmlformats.org/drawingml/2006/main"/>
+          <a:ln xmlns:a="http://schemas.openxmlformats.org/drawingml/2006/main" w="0">
+            <a:noFill/>
+          </a:ln>
+        </p:spPr>
+        <p:txBody>
+          <a:bodyPr xmlns:a="http://schemas.openxmlformats.org/drawingml/2006/main">
+            <a:normAutofit fontScale="100000"/>
+          </a:bodyPr>
+          <a:lstStyle xmlns:a="http://schemas.openxmlformats.org/drawingml/2006/main"/>
+          <a:p xmlns:a="http://schemas.openxmlformats.org/drawingml/2006/main">
+            <a:pPr>
+              <a:defRPr sz="1125" b="1">
+                <a:solidFill>
+                  <a:srgbClr val="6CC7FF"/>
+                </a:solidFill>
+                <a:latin typeface="Arial"/>
+                <a:ea typeface="Arial"/>
+                <a:cs typeface="Arial"/>
+              </a:defRPr>
+            </a:pPr>
+            <a:r>
+              <a:rPr sz="1125" b="1">
+                <a:solidFill>
+                  <a:srgbClr val="6CC7FF"/>
+                </a:solidFill>
+                <a:latin typeface="Arial"/>
+                <a:ea typeface="Arial"/>
+                <a:cs typeface="Arial"/>
+              </a:rPr>
+              <a:t>OPTURON</a:t>
+            </a:r>
+          </a:p>
+        </p:txBody>
+      </p:sp>
+      <p:sp>
+        <p:nvSpPr>
+          <p:cNvPr id="2" name="">
+            <a:extLst xmlns:a="http://schemas.openxmlformats.org/drawingml/2006/main">
+              <a:ext uri="{FF2B5EF4-FFF2-40B4-BE49-F238E27FC236}">
+                <a16:creationId xmlns:a16="http://schemas.microsoft.com/office/drawing/2014/main" id="{82C88D12-7929-4308-A841-2F19AC06BF3F}"/>
+              </a:ext>
+            </a:extLst>
+          </p:cNvPr>
+          <p:cNvSpPr>
+            <a:spLocks xmlns:a="http://schemas.openxmlformats.org/drawingml/2006/main" noGrp="1"/>
+          </p:cNvSpPr>
+          <p:nvPr/>
+        </p:nvSpPr>
+        <p:spPr>
+          <a:xfrm xmlns:a="http://schemas.openxmlformats.org/drawingml/2006/main">
+            <a:off x="685800" y="990600"/>
+            <a:ext cx="10001250" cy="266700"/>
+          </a:xfrm>
+          <a:prstGeom xmlns:a="http://schemas.openxmlformats.org/drawingml/2006/main" prst="rect">
+            <a:avLst/>
+          </a:prstGeom>
+          <a:noFill xmlns:a="http://schemas.openxmlformats.org/drawingml/2006/main"/>
+          <a:ln xmlns:a="http://schemas.openxmlformats.org/drawingml/2006/main" w="0">
+            <a:noFill/>
+          </a:ln>
+        </p:spPr>
+        <p:txBody>
+          <a:bodyPr xmlns:a="http://schemas.openxmlformats.org/drawingml/2006/main">
+            <a:normAutofit fontScale="95833"/>
+          </a:bodyPr>
+          <a:lstStyle xmlns:a="http://schemas.openxmlformats.org/drawingml/2006/main"/>
+          <a:p xmlns:a="http://schemas.openxmlformats.org/drawingml/2006/main">
+            <a:pPr>
+              <a:defRPr sz="1200" b="1">
+                <a:solidFill>
+                  <a:srgbClr val="FFB15C"/>
+                </a:solidFill>
+                <a:latin typeface="Arial"/>
+                <a:ea typeface="Arial"/>
+                <a:cs typeface="Arial"/>
+              </a:defRPr>
+            </a:pPr>
+            <a:r>
+              <a:rPr sz="1200" b="1">
+                <a:solidFill>
+                  <a:srgbClr val="FFB15C"/>
+                </a:solidFill>
+                <a:latin typeface="Arial"/>
+                <a:ea typeface="Arial"/>
+                <a:cs typeface="Arial"/>
+              </a:rPr>
+              <a:t>PRÓXIMOS PASOS</a:t>
+            </a:r>
+          </a:p>
+        </p:txBody>
+      </p:sp>
+      <p:sp>
+        <p:nvSpPr>
+          <p:cNvPr id="3" name="">
+            <a:extLst xmlns:a="http://schemas.openxmlformats.org/drawingml/2006/main">
+              <a:ext uri="{FF2B5EF4-FFF2-40B4-BE49-F238E27FC236}">
+                <a16:creationId xmlns:a16="http://schemas.microsoft.com/office/drawing/2014/main" id="{F3EB4123-2147-42A7-8713-375EF66B893A}"/>
+              </a:ext>
+            </a:extLst>
+          </p:cNvPr>
+          <p:cNvSpPr>
+            <a:spLocks xmlns:a="http://schemas.openxmlformats.org/drawingml/2006/main" noGrp="1"/>
+          </p:cNvSpPr>
+          <p:nvPr/>
+        </p:nvSpPr>
+        <p:spPr>
+          <a:xfrm xmlns:a="http://schemas.openxmlformats.org/drawingml/2006/main">
+            <a:off x="685800" y="1371600"/>
+            <a:ext cx="10668000" cy="952500"/>
+          </a:xfrm>
+          <a:prstGeom xmlns:a="http://schemas.openxmlformats.org/drawingml/2006/main" prst="rect">
+            <a:avLst/>
+          </a:prstGeom>
+          <a:noFill xmlns:a="http://schemas.openxmlformats.org/drawingml/2006/main"/>
+          <a:ln xmlns:a="http://schemas.openxmlformats.org/drawingml/2006/main" w="0">
+            <a:noFill/>
+          </a:ln>
+        </p:spPr>
+        <p:txBody>
+          <a:bodyPr xmlns:a="http://schemas.openxmlformats.org/drawingml/2006/main">
+            <a:normAutofit fontScale="100000"/>
+          </a:bodyPr>
+          <a:lstStyle xmlns:a="http://schemas.openxmlformats.org/drawingml/2006/main"/>
+          <a:p xmlns:a="http://schemas.openxmlformats.org/drawingml/2006/main">
+            <a:pPr>
+              <a:defRPr sz="2850" b="1">
+                <a:solidFill>
+                  <a:srgbClr val="F8FBFF"/>
+                </a:solidFill>
+                <a:latin typeface="Arial"/>
+                <a:ea typeface="Arial"/>
+                <a:cs typeface="Arial"/>
+              </a:defRPr>
+            </a:pPr>
+            <a:r>
+              <a:rPr sz="2850" b="1">
+                <a:solidFill>
+                  <a:srgbClr val="F8FBFF"/>
+                </a:solidFill>
+                <a:latin typeface="Arial"/>
+                <a:ea typeface="Arial"/>
+                <a:cs typeface="Arial"/>
+              </a:rPr>
+              <a:t>Empezá con claridad</a:t>
+            </a:r>
+          </a:p>
+        </p:txBody>
+      </p:sp>
+      <p:sp>
+        <p:nvSpPr>
+          <p:cNvPr id="4" name="">
+            <a:extLst xmlns:a="http://schemas.openxmlformats.org/drawingml/2006/main">
+              <a:ext uri="{FF2B5EF4-FFF2-40B4-BE49-F238E27FC236}">
+                <a16:creationId xmlns:a16="http://schemas.microsoft.com/office/drawing/2014/main" id="{33D479B5-9E77-4EBF-B2AB-23795EFF2E74}"/>
+              </a:ext>
+            </a:extLst>
+          </p:cNvPr>
+          <p:cNvSpPr>
+            <a:spLocks xmlns:a="http://schemas.openxmlformats.org/drawingml/2006/main" noGrp="1"/>
+          </p:cNvSpPr>
+          <p:nvPr/>
+        </p:nvSpPr>
+        <p:spPr>
+          <a:xfrm xmlns:a="http://schemas.openxmlformats.org/drawingml/2006/main">
+            <a:off x="819150" y="2857500"/>
+            <a:ext cx="3429000" cy="285750"/>
+          </a:xfrm>
+          <a:prstGeom xmlns:a="http://schemas.openxmlformats.org/drawingml/2006/main" prst="rect">
+            <a:avLst/>
+          </a:prstGeom>
+          <a:noFill xmlns:a="http://schemas.openxmlformats.org/drawingml/2006/main"/>
+          <a:ln xmlns:a="http://schemas.openxmlformats.org/drawingml/2006/main" w="0">
+            <a:noFill/>
+          </a:ln>
+        </p:spPr>
+        <p:txBody>
+          <a:bodyPr xmlns:a="http://schemas.openxmlformats.org/drawingml/2006/main">
+            <a:normAutofit fontScale="89474"/>
+          </a:bodyPr>
+          <a:lstStyle xmlns:a="http://schemas.openxmlformats.org/drawingml/2006/main"/>
+          <a:p xmlns:a="http://schemas.openxmlformats.org/drawingml/2006/main">
+            <a:pPr>
+              <a:defRPr sz="1425" b="1">
+                <a:solidFill>
+                  <a:srgbClr val="73C9FF"/>
+                </a:solidFill>
+                <a:latin typeface="Arial"/>
+                <a:ea typeface="Arial"/>
+                <a:cs typeface="Arial"/>
+              </a:defRPr>
+            </a:pPr>
+            <a:r>
+              <a:rPr sz="1425" b="1">
+                <a:solidFill>
+                  <a:srgbClr val="73C9FF"/>
+                </a:solidFill>
+                <a:latin typeface="Arial"/>
+                <a:ea typeface="Arial"/>
+                <a:cs typeface="Arial"/>
+              </a:rPr>
+              <a:t>Si todavía no activaste</a:t>
+            </a:r>
+          </a:p>
+        </p:txBody>
+      </p:sp>
+      <p:sp>
+        <p:nvSpPr>
+          <p:cNvPr id="5" name="">
+            <a:extLst xmlns:a="http://schemas.openxmlformats.org/drawingml/2006/main">
+              <a:ext uri="{FF2B5EF4-FFF2-40B4-BE49-F238E27FC236}">
+                <a16:creationId xmlns:a16="http://schemas.microsoft.com/office/drawing/2014/main" id="{46D963F0-163E-4906-A8AC-058893FDE07A}"/>
+              </a:ext>
+            </a:extLst>
+          </p:cNvPr>
+          <p:cNvSpPr>
+            <a:spLocks xmlns:a="http://schemas.openxmlformats.org/drawingml/2006/main" noGrp="1"/>
+          </p:cNvSpPr>
+          <p:nvPr/>
+        </p:nvSpPr>
+        <p:spPr>
+          <a:xfrm xmlns:a="http://schemas.openxmlformats.org/drawingml/2006/main">
+            <a:off x="4476750" y="2857500"/>
+            <a:ext cx="6667500" cy="533400"/>
+          </a:xfrm>
+          <a:prstGeom xmlns:a="http://schemas.openxmlformats.org/drawingml/2006/main" prst="rect">
+            <a:avLst/>
+          </a:prstGeom>
+          <a:noFill xmlns:a="http://schemas.openxmlformats.org/drawingml/2006/main"/>
+          <a:ln xmlns:a="http://schemas.openxmlformats.org/drawingml/2006/main" w="0">
+            <a:noFill/>
+          </a:ln>
+        </p:spPr>
+        <p:txBody>
+          <a:bodyPr xmlns:a="http://schemas.openxmlformats.org/drawingml/2006/main">
+            <a:normAutofit fontScale="100000"/>
+          </a:bodyPr>
+          <a:lstStyle xmlns:a="http://schemas.openxmlformats.org/drawingml/2006/main"/>
+          <a:p xmlns:a="http://schemas.openxmlformats.org/drawingml/2006/main">
+            <a:pPr>
+              <a:defRPr sz="1425" b="0">
+                <a:solidFill>
+                  <a:srgbClr val="DCE8F6"/>
+                </a:solidFill>
+                <a:latin typeface="Arial"/>
+                <a:ea typeface="Arial"/>
+                <a:cs typeface="Arial"/>
+              </a:defRPr>
+            </a:pPr>
+            <a:r>
+              <a:rPr sz="1425" b="0">
+                <a:solidFill>
+                  <a:srgbClr val="DCE8F6"/>
+                </a:solidFill>
+                <a:latin typeface="Arial"/>
+                <a:ea typeface="Arial"/>
+                <a:cs typeface="Arial"/>
+              </a:rPr>
+              <a:t>Volvé a la contratación desde tu cuenta y completá la autorización.</a:t>
+            </a:r>
+          </a:p>
+        </p:txBody>
+      </p:sp>
+      <p:sp>
+        <p:nvSpPr>
+          <p:cNvPr id="6" name="">
+            <a:extLst xmlns:a="http://schemas.openxmlformats.org/drawingml/2006/main">
+              <a:ext uri="{FF2B5EF4-FFF2-40B4-BE49-F238E27FC236}">
+                <a16:creationId xmlns:a16="http://schemas.microsoft.com/office/drawing/2014/main" id="{AA6469B0-3B04-4D7A-909D-5B4408020506}"/>
+              </a:ext>
+            </a:extLst>
+          </p:cNvPr>
+          <p:cNvSpPr>
+            <a:spLocks xmlns:a="http://schemas.openxmlformats.org/drawingml/2006/main" noGrp="1"/>
+          </p:cNvSpPr>
+          <p:nvPr/>
+        </p:nvSpPr>
+        <p:spPr>
+          <a:xfrm xmlns:a="http://schemas.openxmlformats.org/drawingml/2006/main">
+            <a:off x="819150" y="3543300"/>
+            <a:ext cx="3429000" cy="285750"/>
+          </a:xfrm>
+          <a:prstGeom xmlns:a="http://schemas.openxmlformats.org/drawingml/2006/main" prst="rect">
+            <a:avLst/>
+          </a:prstGeom>
+          <a:noFill xmlns:a="http://schemas.openxmlformats.org/drawingml/2006/main"/>
+          <a:ln xmlns:a="http://schemas.openxmlformats.org/drawingml/2006/main" w="0">
+            <a:noFill/>
+          </a:ln>
+        </p:spPr>
+        <p:txBody>
+          <a:bodyPr xmlns:a="http://schemas.openxmlformats.org/drawingml/2006/main">
+            <a:normAutofit fontScale="89474"/>
+          </a:bodyPr>
+          <a:lstStyle xmlns:a="http://schemas.openxmlformats.org/drawingml/2006/main"/>
+          <a:p xmlns:a="http://schemas.openxmlformats.org/drawingml/2006/main">
+            <a:pPr>
+              <a:defRPr sz="1425" b="1">
+                <a:solidFill>
+                  <a:srgbClr val="73C9FF"/>
+                </a:solidFill>
+                <a:latin typeface="Arial"/>
+                <a:ea typeface="Arial"/>
+                <a:cs typeface="Arial"/>
+              </a:defRPr>
+            </a:pPr>
+            <a:r>
+              <a:rPr sz="1425" b="1">
+                <a:solidFill>
+                  <a:srgbClr val="73C9FF"/>
+                </a:solidFill>
+                <a:latin typeface="Arial"/>
+                <a:ea typeface="Arial"/>
+                <a:cs typeface="Arial"/>
+              </a:rPr>
+              <a:t>Soporte</a:t>
+            </a:r>
+          </a:p>
+        </p:txBody>
+      </p:sp>
+      <p:sp>
+        <p:nvSpPr>
+          <p:cNvPr id="7" name="">
+            <a:extLst xmlns:a="http://schemas.openxmlformats.org/drawingml/2006/main">
+              <a:ext uri="{FF2B5EF4-FFF2-40B4-BE49-F238E27FC236}">
+                <a16:creationId xmlns:a16="http://schemas.microsoft.com/office/drawing/2014/main" id="{F1E1FE09-9812-4C16-ABD3-C2E171BACB7E}"/>
+              </a:ext>
+            </a:extLst>
+          </p:cNvPr>
+          <p:cNvSpPr>
+            <a:spLocks xmlns:a="http://schemas.openxmlformats.org/drawingml/2006/main" noGrp="1"/>
+          </p:cNvSpPr>
+          <p:nvPr/>
+        </p:nvSpPr>
+        <p:spPr>
+          <a:xfrm xmlns:a="http://schemas.openxmlformats.org/drawingml/2006/main">
+            <a:off x="4476750" y="3543300"/>
+            <a:ext cx="6667500" cy="533400"/>
+          </a:xfrm>
+          <a:prstGeom xmlns:a="http://schemas.openxmlformats.org/drawingml/2006/main" prst="rect">
+            <a:avLst/>
+          </a:prstGeom>
+          <a:noFill xmlns:a="http://schemas.openxmlformats.org/drawingml/2006/main"/>
+          <a:ln xmlns:a="http://schemas.openxmlformats.org/drawingml/2006/main" w="0">
+            <a:noFill/>
+          </a:ln>
+        </p:spPr>
+        <p:txBody>
+          <a:bodyPr xmlns:a="http://schemas.openxmlformats.org/drawingml/2006/main">
+            <a:normAutofit fontScale="100000"/>
+          </a:bodyPr>
+          <a:lstStyle xmlns:a="http://schemas.openxmlformats.org/drawingml/2006/main"/>
+          <a:p xmlns:a="http://schemas.openxmlformats.org/drawingml/2006/main">
+            <a:pPr>
+              <a:defRPr sz="1425" b="0">
+                <a:solidFill>
+                  <a:srgbClr val="DCE8F6"/>
+                </a:solidFill>
+                <a:latin typeface="Arial"/>
+                <a:ea typeface="Arial"/>
+                <a:cs typeface="Arial"/>
+              </a:defRPr>
+            </a:pPr>
+            <a:r>
+              <a:rPr sz="1425" b="0">
+                <a:solidFill>
+                  <a:srgbClr val="DCE8F6"/>
+                </a:solidFill>
+                <a:latin typeface="Arial"/>
+                <a:ea typeface="Arial"/>
+                <a:cs typeface="Arial"/>
+              </a:rPr>
+              <a:t>Si necesitás ayuda, usá el canal de contacto de Opturon.</a:t>
+            </a:r>
+          </a:p>
+        </p:txBody>
+      </p:sp>
+      <p:sp>
+        <p:nvSpPr>
+          <p:cNvPr id="8" name="">
+            <a:extLst xmlns:a="http://schemas.openxmlformats.org/drawingml/2006/main">
+              <a:ext uri="{FF2B5EF4-FFF2-40B4-BE49-F238E27FC236}">
+                <a16:creationId xmlns:a16="http://schemas.microsoft.com/office/drawing/2014/main" id="{AEA5FB1D-4D4C-4126-A469-F68ED2D9EC4E}"/>
+              </a:ext>
+            </a:extLst>
+          </p:cNvPr>
+          <p:cNvSpPr>
+            <a:spLocks xmlns:a="http://schemas.openxmlformats.org/drawingml/2006/main" noGrp="1"/>
+          </p:cNvSpPr>
+          <p:nvPr/>
+        </p:nvSpPr>
+        <p:spPr>
+          <a:xfrm xmlns:a="http://schemas.openxmlformats.org/drawingml/2006/main">
+            <a:off x="685800" y="6400800"/>
+            <a:ext cx="3810000" cy="190500"/>
+          </a:xfrm>
+          <a:prstGeom xmlns:a="http://schemas.openxmlformats.org/drawingml/2006/main" prst="rect">
+            <a:avLst/>
+          </a:prstGeom>
+          <a:noFill xmlns:a="http://schemas.openxmlformats.org/drawingml/2006/main"/>
+          <a:ln xmlns:a="http://schemas.openxmlformats.org/drawingml/2006/main" w="0">
+            <a:noFill/>
+          </a:ln>
+        </p:spPr>
+        <p:txBody>
+          <a:bodyPr xmlns:a="http://schemas.openxmlformats.org/drawingml/2006/main">
+            <a:normAutofit fontScale="72222"/>
+          </a:bodyPr>
+          <a:lstStyle xmlns:a="http://schemas.openxmlformats.org/drawingml/2006/main"/>
+          <a:p xmlns:a="http://schemas.openxmlformats.org/drawingml/2006/main">
+            <a:pPr>
+              <a:defRPr sz="900" b="0">
+                <a:solidFill>
+                  <a:srgbClr val="7E95AF"/>
+                </a:solidFill>
+                <a:latin typeface="Arial"/>
+                <a:ea typeface="Arial"/>
+                <a:cs typeface="Arial"/>
+              </a:defRPr>
+            </a:pPr>
+            <a:r>
+              <a:rPr sz="900" b="0">
+                <a:solidFill>
+                  <a:srgbClr val="7E95AF"/>
+                </a:solidFill>
+                <a:latin typeface="Arial"/>
+                <a:ea typeface="Arial"/>
+                <a:cs typeface="Arial"/>
+              </a:rPr>
+              <a:t>opturon.com</a:t>
+            </a:r>
+          </a:p>
+        </p:txBody>
+      </p:sp>
+    </p:spTree>
+    <p:extLst>
+      <p:ext uri="{BB962C8B-B14F-4D97-AF65-F5344CB8AC3E}">
+        <p14:creationId xmlns:p14="http://schemas.microsoft.com/office/powerpoint/2010/main" val="1189371960"/>
       </p:ext>
     </p:extLst>
   </p:cSld>
@@ -2613,7 +3055,7 @@
           <p:cNvPr id="9" name="">
             <a:extLst xmlns:a="http://schemas.openxmlformats.org/drawingml/2006/main">
               <a:ext uri="{FF2B5EF4-FFF2-40B4-BE49-F238E27FC236}">
-                <a16:creationId xmlns:a16="http://schemas.microsoft.com/office/drawing/2014/main" id="{8CAF34AD-BF5F-4CF4-90DC-A7CF67C5673A}"/>
+                <a16:creationId xmlns:a16="http://schemas.microsoft.com/office/drawing/2014/main" id="{16194C0F-14E5-4AF5-A487-A5DEDB666544}"/>
               </a:ext>
             </a:extLst>
           </p:cNvPr>
@@ -2670,7 +3112,7 @@
           <p:cNvPr id="2" name="">
             <a:extLst xmlns:a="http://schemas.openxmlformats.org/drawingml/2006/main">
               <a:ext uri="{FF2B5EF4-FFF2-40B4-BE49-F238E27FC236}">
-                <a16:creationId xmlns:a16="http://schemas.microsoft.com/office/drawing/2014/main" id="{C4AC1F33-9709-4C94-92C0-ADB70276DD79}"/>
+                <a16:creationId xmlns:a16="http://schemas.microsoft.com/office/drawing/2014/main" id="{42954843-E1A9-4002-93EE-33B080252E0E}"/>
               </a:ext>
             </a:extLst>
           </p:cNvPr>
@@ -2727,7 +3169,7 @@
           <p:cNvPr id="3" name="">
             <a:extLst xmlns:a="http://schemas.openxmlformats.org/drawingml/2006/main">
               <a:ext uri="{FF2B5EF4-FFF2-40B4-BE49-F238E27FC236}">
-                <a16:creationId xmlns:a16="http://schemas.microsoft.com/office/drawing/2014/main" id="{FDE90151-C1F7-4E15-9B5B-4838786449AF}"/>
+                <a16:creationId xmlns:a16="http://schemas.microsoft.com/office/drawing/2014/main" id="{EBAE5CA5-D944-4AF9-B538-3E0CD141241F}"/>
               </a:ext>
             </a:extLst>
           </p:cNvPr>
@@ -2784,7 +3226,7 @@
           <p:cNvPr id="4" name="">
             <a:extLst xmlns:a="http://schemas.openxmlformats.org/drawingml/2006/main">
               <a:ext uri="{FF2B5EF4-FFF2-40B4-BE49-F238E27FC236}">
-                <a16:creationId xmlns:a16="http://schemas.microsoft.com/office/drawing/2014/main" id="{FAFF3C32-98ED-4BAA-84EC-D9C0243A6643}"/>
+                <a16:creationId xmlns:a16="http://schemas.microsoft.com/office/drawing/2014/main" id="{E9DC7E64-C6CF-4867-9753-5CC9915081D1}"/>
               </a:ext>
             </a:extLst>
           </p:cNvPr>
@@ -2841,7 +3283,7 @@
           <p:cNvPr id="5" name="">
             <a:extLst xmlns:a="http://schemas.openxmlformats.org/drawingml/2006/main">
               <a:ext uri="{FF2B5EF4-FFF2-40B4-BE49-F238E27FC236}">
-                <a16:creationId xmlns:a16="http://schemas.microsoft.com/office/drawing/2014/main" id="{DA6C7E9A-4F31-44E5-999D-894328845122}"/>
+                <a16:creationId xmlns:a16="http://schemas.microsoft.com/office/drawing/2014/main" id="{93BC1CE0-BFC4-4538-9284-93893EA8D612}"/>
               </a:ext>
             </a:extLst>
           </p:cNvPr>
@@ -2898,7 +3340,7 @@
           <p:cNvPr id="6" name="">
             <a:extLst xmlns:a="http://schemas.openxmlformats.org/drawingml/2006/main">
               <a:ext uri="{FF2B5EF4-FFF2-40B4-BE49-F238E27FC236}">
-                <a16:creationId xmlns:a16="http://schemas.microsoft.com/office/drawing/2014/main" id="{68BECF12-976E-46DF-BC73-509A5C121DE0}"/>
+                <a16:creationId xmlns:a16="http://schemas.microsoft.com/office/drawing/2014/main" id="{948EC7AA-15AB-4F70-BEE1-E92C39330DB3}"/>
               </a:ext>
             </a:extLst>
           </p:cNvPr>
@@ -2955,7 +3397,7 @@
           <p:cNvPr id="7" name="">
             <a:extLst xmlns:a="http://schemas.openxmlformats.org/drawingml/2006/main">
               <a:ext uri="{FF2B5EF4-FFF2-40B4-BE49-F238E27FC236}">
-                <a16:creationId xmlns:a16="http://schemas.microsoft.com/office/drawing/2014/main" id="{0174DAD0-4CE7-451C-BF11-E21C2C8E04D8}"/>
+                <a16:creationId xmlns:a16="http://schemas.microsoft.com/office/drawing/2014/main" id="{454AC3FA-0542-494C-AA9B-76D16F3D7AFB}"/>
               </a:ext>
             </a:extLst>
           </p:cNvPr>
@@ -3012,7 +3454,7 @@
           <p:cNvPr id="8" name="">
             <a:extLst xmlns:a="http://schemas.openxmlformats.org/drawingml/2006/main">
               <a:ext uri="{FF2B5EF4-FFF2-40B4-BE49-F238E27FC236}">
-                <a16:creationId xmlns:a16="http://schemas.microsoft.com/office/drawing/2014/main" id="{F143AFE0-F6FC-4646-9FF5-B166DBA51751}"/>
+                <a16:creationId xmlns:a16="http://schemas.microsoft.com/office/drawing/2014/main" id="{3E6A736A-B27E-4D46-91F5-2539C4432438}"/>
               </a:ext>
             </a:extLst>
           </p:cNvPr>
@@ -3067,7 +3509,7 @@
     </p:spTree>
     <p:extLst>
       <p:ext uri="{BB962C8B-B14F-4D97-AF65-F5344CB8AC3E}">
-        <p14:creationId xmlns:p14="http://schemas.microsoft.com/office/powerpoint/2010/main" val="574283391"/>
+        <p14:creationId xmlns:p14="http://schemas.microsoft.com/office/powerpoint/2010/main" val="120889996"/>
       </p:ext>
     </p:extLst>
   </p:cSld>
@@ -3098,7 +3540,7 @@
           <p:cNvPr id="9" name="">
             <a:extLst xmlns:a="http://schemas.openxmlformats.org/drawingml/2006/main">
               <a:ext uri="{FF2B5EF4-FFF2-40B4-BE49-F238E27FC236}">
-                <a16:creationId xmlns:a16="http://schemas.microsoft.com/office/drawing/2014/main" id="{D6D4DDC8-6CD2-4720-9C2B-AF390A6050E1}"/>
+                <a16:creationId xmlns:a16="http://schemas.microsoft.com/office/drawing/2014/main" id="{91320229-9B2D-4EC4-9832-4EFDDE47CCD6}"/>
               </a:ext>
             </a:extLst>
           </p:cNvPr>
@@ -3155,7 +3597,7 @@
           <p:cNvPr id="2" name="">
             <a:extLst xmlns:a="http://schemas.openxmlformats.org/drawingml/2006/main">
               <a:ext uri="{FF2B5EF4-FFF2-40B4-BE49-F238E27FC236}">
-                <a16:creationId xmlns:a16="http://schemas.microsoft.com/office/drawing/2014/main" id="{E507A4A8-1563-4F4F-AE1F-941BE551BFEA}"/>
+                <a16:creationId xmlns:a16="http://schemas.microsoft.com/office/drawing/2014/main" id="{42759374-D99A-4613-B0DD-929233814073}"/>
               </a:ext>
             </a:extLst>
           </p:cNvPr>
@@ -3212,7 +3654,7 @@
           <p:cNvPr id="3" name="">
             <a:extLst xmlns:a="http://schemas.openxmlformats.org/drawingml/2006/main">
               <a:ext uri="{FF2B5EF4-FFF2-40B4-BE49-F238E27FC236}">
-                <a16:creationId xmlns:a16="http://schemas.microsoft.com/office/drawing/2014/main" id="{81496189-5857-4539-B083-045A480BE8B6}"/>
+                <a16:creationId xmlns:a16="http://schemas.microsoft.com/office/drawing/2014/main" id="{73BA4C0E-AB29-4159-8DDE-D288BE252174}"/>
               </a:ext>
             </a:extLst>
           </p:cNvPr>
@@ -3269,7 +3711,7 @@
           <p:cNvPr id="4" name="">
             <a:extLst xmlns:a="http://schemas.openxmlformats.org/drawingml/2006/main">
               <a:ext uri="{FF2B5EF4-FFF2-40B4-BE49-F238E27FC236}">
-                <a16:creationId xmlns:a16="http://schemas.microsoft.com/office/drawing/2014/main" id="{6C58E9EA-B5A8-434C-BBD9-1D713148F646}"/>
+                <a16:creationId xmlns:a16="http://schemas.microsoft.com/office/drawing/2014/main" id="{0DABA080-EB90-4B61-AE56-3690A099ED52}"/>
               </a:ext>
             </a:extLst>
           </p:cNvPr>
@@ -3326,7 +3768,7 @@
           <p:cNvPr id="5" name="">
             <a:extLst xmlns:a="http://schemas.openxmlformats.org/drawingml/2006/main">
               <a:ext uri="{FF2B5EF4-FFF2-40B4-BE49-F238E27FC236}">
-                <a16:creationId xmlns:a16="http://schemas.microsoft.com/office/drawing/2014/main" id="{63F5C9C3-5991-4E8B-8397-D838857E2A65}"/>
+                <a16:creationId xmlns:a16="http://schemas.microsoft.com/office/drawing/2014/main" id="{53B7C1AA-5101-4919-8FFF-D4561E669A56}"/>
               </a:ext>
             </a:extLst>
           </p:cNvPr>
@@ -3383,7 +3825,7 @@
           <p:cNvPr id="6" name="">
             <a:extLst xmlns:a="http://schemas.openxmlformats.org/drawingml/2006/main">
               <a:ext uri="{FF2B5EF4-FFF2-40B4-BE49-F238E27FC236}">
-                <a16:creationId xmlns:a16="http://schemas.microsoft.com/office/drawing/2014/main" id="{5103D1CE-65D4-4E39-B77E-5D7CFEBAABAD}"/>
+                <a16:creationId xmlns:a16="http://schemas.microsoft.com/office/drawing/2014/main" id="{0118EC63-FEDC-4584-9DAB-0F70BEEC1934}"/>
               </a:ext>
             </a:extLst>
           </p:cNvPr>
@@ -3440,7 +3882,7 @@
           <p:cNvPr id="7" name="">
             <a:extLst xmlns:a="http://schemas.openxmlformats.org/drawingml/2006/main">
               <a:ext uri="{FF2B5EF4-FFF2-40B4-BE49-F238E27FC236}">
-                <a16:creationId xmlns:a16="http://schemas.microsoft.com/office/drawing/2014/main" id="{C78A0E6B-7C43-41E2-9900-28ACBE152F83}"/>
+                <a16:creationId xmlns:a16="http://schemas.microsoft.com/office/drawing/2014/main" id="{94C4FE9E-8794-4097-9275-7428042BACCC}"/>
               </a:ext>
             </a:extLst>
           </p:cNvPr>
@@ -3497,7 +3939,7 @@
           <p:cNvPr id="8" name="">
             <a:extLst xmlns:a="http://schemas.openxmlformats.org/drawingml/2006/main">
               <a:ext uri="{FF2B5EF4-FFF2-40B4-BE49-F238E27FC236}">
-                <a16:creationId xmlns:a16="http://schemas.microsoft.com/office/drawing/2014/main" id="{16C1FF74-AD0C-483B-A10C-6C7068C86208}"/>
+                <a16:creationId xmlns:a16="http://schemas.microsoft.com/office/drawing/2014/main" id="{40EE5F74-5FB0-48D1-9499-67E27B19BCFD}"/>
               </a:ext>
             </a:extLst>
           </p:cNvPr>
@@ -3552,7 +3994,7 @@
     </p:spTree>
     <p:extLst>
       <p:ext uri="{BB962C8B-B14F-4D97-AF65-F5344CB8AC3E}">
-        <p14:creationId xmlns:p14="http://schemas.microsoft.com/office/powerpoint/2010/main" val="576635144"/>
+        <p14:creationId xmlns:p14="http://schemas.microsoft.com/office/powerpoint/2010/main" val="2059808984"/>
       </p:ext>
     </p:extLst>
   </p:cSld>
@@ -3583,7 +4025,7 @@
           <p:cNvPr id="11" name="">
             <a:extLst xmlns:a="http://schemas.openxmlformats.org/drawingml/2006/main">
               <a:ext uri="{FF2B5EF4-FFF2-40B4-BE49-F238E27FC236}">
-                <a16:creationId xmlns:a16="http://schemas.microsoft.com/office/drawing/2014/main" id="{45CDF24A-F180-4AC2-A026-662B3C181F52}"/>
+                <a16:creationId xmlns:a16="http://schemas.microsoft.com/office/drawing/2014/main" id="{A155161A-313B-4936-86F8-9DB82FDE3283}"/>
               </a:ext>
             </a:extLst>
           </p:cNvPr>
@@ -3640,7 +4082,7 @@
           <p:cNvPr id="2" name="">
             <a:extLst xmlns:a="http://schemas.openxmlformats.org/drawingml/2006/main">
               <a:ext uri="{FF2B5EF4-FFF2-40B4-BE49-F238E27FC236}">
-                <a16:creationId xmlns:a16="http://schemas.microsoft.com/office/drawing/2014/main" id="{23010A4A-18B1-4F2D-8535-5DE1D010B789}"/>
+                <a16:creationId xmlns:a16="http://schemas.microsoft.com/office/drawing/2014/main" id="{7047F1AF-2052-418F-BF38-F608F968DAED}"/>
               </a:ext>
             </a:extLst>
           </p:cNvPr>
@@ -3687,7 +4129,7 @@
                 <a:ea typeface="Arial"/>
                 <a:cs typeface="Arial"/>
               </a:rPr>
-              <a:t>CONTRATACIÓN</a:t>
+              <a:t>CONFIGURACIÓN INICIAL</a:t>
             </a:r>
           </a:p>
         </p:txBody>
@@ -3697,7 +4139,7 @@
           <p:cNvPr id="3" name="">
             <a:extLst xmlns:a="http://schemas.openxmlformats.org/drawingml/2006/main">
               <a:ext uri="{FF2B5EF4-FFF2-40B4-BE49-F238E27FC236}">
-                <a16:creationId xmlns:a16="http://schemas.microsoft.com/office/drawing/2014/main" id="{7119DDC6-F4BD-4F4E-8727-954AEF69962A}"/>
+                <a16:creationId xmlns:a16="http://schemas.microsoft.com/office/drawing/2014/main" id="{AD6CD015-F3FC-4C1A-98D8-B827DADF883A}"/>
               </a:ext>
             </a:extLst>
           </p:cNvPr>
@@ -3744,7 +4186,7 @@
                 <a:ea typeface="Arial"/>
                 <a:cs typeface="Arial"/>
               </a:rPr>
-              <a:t>Cómo completar la contratación</a:t>
+              <a:t>Tu asistente IA</a:t>
             </a:r>
           </a:p>
         </p:txBody>
@@ -3754,7 +4196,7 @@
           <p:cNvPr id="4" name="">
             <a:extLst xmlns:a="http://schemas.openxmlformats.org/drawingml/2006/main">
               <a:ext uri="{FF2B5EF4-FFF2-40B4-BE49-F238E27FC236}">
-                <a16:creationId xmlns:a16="http://schemas.microsoft.com/office/drawing/2014/main" id="{CD37199B-A3AC-4669-BF08-ADAB9540A225}"/>
+                <a16:creationId xmlns:a16="http://schemas.microsoft.com/office/drawing/2014/main" id="{5F9875DD-AF3F-4709-98C8-4D0E248F8CD1}"/>
               </a:ext>
             </a:extLst>
           </p:cNvPr>
@@ -3801,7 +4243,7 @@
                 <a:ea typeface="Arial"/>
                 <a:cs typeface="Arial"/>
               </a:rPr>
-              <a:t>1. Elegí</a:t>
+              <a:t>Después del pago</a:t>
             </a:r>
           </a:p>
         </p:txBody>
@@ -3811,7 +4253,7 @@
           <p:cNvPr id="5" name="">
             <a:extLst xmlns:a="http://schemas.openxmlformats.org/drawingml/2006/main">
               <a:ext uri="{FF2B5EF4-FFF2-40B4-BE49-F238E27FC236}">
-                <a16:creationId xmlns:a16="http://schemas.microsoft.com/office/drawing/2014/main" id="{65FAC01E-EA7C-4B88-8517-E7D06C204F4E}"/>
+                <a16:creationId xmlns:a16="http://schemas.microsoft.com/office/drawing/2014/main" id="{71C93F66-5ACF-4AB4-AA2E-CD985385D96A}"/>
               </a:ext>
             </a:extLst>
           </p:cNvPr>
@@ -3858,7 +4300,7 @@
                 <a:ea typeface="Arial"/>
                 <a:cs typeface="Arial"/>
               </a:rPr>
-              <a:t>Seleccioná el plan que mejor representa tu operación.</a:t>
+              <a:t>Cuando tu pago queda aprobado, el equipo prepara la configuración inicial del asistente según tu plan.</a:t>
             </a:r>
           </a:p>
         </p:txBody>
@@ -3868,7 +4310,7 @@
           <p:cNvPr id="6" name="">
             <a:extLst xmlns:a="http://schemas.openxmlformats.org/drawingml/2006/main">
               <a:ext uri="{FF2B5EF4-FFF2-40B4-BE49-F238E27FC236}">
-                <a16:creationId xmlns:a16="http://schemas.microsoft.com/office/drawing/2014/main" id="{351514B1-EFE9-485A-A873-6C35FCCD80CE}"/>
+                <a16:creationId xmlns:a16="http://schemas.microsoft.com/office/drawing/2014/main" id="{5DB9043B-2205-4EC8-9CD4-D1A661871A56}"/>
               </a:ext>
             </a:extLst>
           </p:cNvPr>
@@ -3915,7 +4357,7 @@
                 <a:ea typeface="Arial"/>
                 <a:cs typeface="Arial"/>
               </a:rPr>
-              <a:t>2. Autorizá</a:t>
+              <a:t>Plazo de referencia</a:t>
             </a:r>
           </a:p>
         </p:txBody>
@@ -3925,7 +4367,7 @@
           <p:cNvPr id="7" name="">
             <a:extLst xmlns:a="http://schemas.openxmlformats.org/drawingml/2006/main">
               <a:ext uri="{FF2B5EF4-FFF2-40B4-BE49-F238E27FC236}">
-                <a16:creationId xmlns:a16="http://schemas.microsoft.com/office/drawing/2014/main" id="{227471FE-D4E1-489C-950F-1E041AF45F0E}"/>
+                <a16:creationId xmlns:a16="http://schemas.microsoft.com/office/drawing/2014/main" id="{4AAE4CB1-70C4-4C15-88B3-198FBF025C6F}"/>
               </a:ext>
             </a:extLst>
           </p:cNvPr>
@@ -3972,7 +4414,7 @@
                 <a:ea typeface="Arial"/>
                 <a:cs typeface="Arial"/>
               </a:rPr>
-              <a:t>Continuá al flujo seguro de Mercado Pago.</a:t>
+              <a:t>La primera configuración puede tardar entre 24 y 48 horas. El resto del espacio sigue disponible durante ese proceso.</a:t>
             </a:r>
           </a:p>
         </p:txBody>
@@ -3982,7 +4424,7 @@
           <p:cNvPr id="8" name="">
             <a:extLst xmlns:a="http://schemas.openxmlformats.org/drawingml/2006/main">
               <a:ext uri="{FF2B5EF4-FFF2-40B4-BE49-F238E27FC236}">
-                <a16:creationId xmlns:a16="http://schemas.microsoft.com/office/drawing/2014/main" id="{25D99A89-1353-4C06-8154-C201AB916F94}"/>
+                <a16:creationId xmlns:a16="http://schemas.microsoft.com/office/drawing/2014/main" id="{956EC1A2-75FE-4934-A92C-34498C8C05B6}"/>
               </a:ext>
             </a:extLst>
           </p:cNvPr>
@@ -4029,7 +4471,7 @@
                 <a:ea typeface="Arial"/>
                 <a:cs typeface="Arial"/>
               </a:rPr>
-              <a:t>3. Confirmá</a:t>
+              <a:t>Estado visible</a:t>
             </a:r>
           </a:p>
         </p:txBody>
@@ -4039,7 +4481,7 @@
           <p:cNvPr id="9" name="">
             <a:extLst xmlns:a="http://schemas.openxmlformats.org/drawingml/2006/main">
               <a:ext uri="{FF2B5EF4-FFF2-40B4-BE49-F238E27FC236}">
-                <a16:creationId xmlns:a16="http://schemas.microsoft.com/office/drawing/2014/main" id="{03D1655C-1085-4620-A267-13485D887379}"/>
+                <a16:creationId xmlns:a16="http://schemas.microsoft.com/office/drawing/2014/main" id="{42FE22F6-AB15-4A03-80C2-22F4F7897BBB}"/>
               </a:ext>
             </a:extLst>
           </p:cNvPr>
@@ -4086,7 +4528,7 @@
                 <a:ea typeface="Arial"/>
                 <a:cs typeface="Arial"/>
               </a:rPr>
-              <a:t>El acceso se habilita cuando el pago queda aprobado.</a:t>
+              <a:t>El Portal muestra si la configuración está pendiente, lista o requiere revisión.</a:t>
             </a:r>
           </a:p>
         </p:txBody>
@@ -4096,7 +4538,7 @@
           <p:cNvPr id="10" name="">
             <a:extLst xmlns:a="http://schemas.openxmlformats.org/drawingml/2006/main">
               <a:ext uri="{FF2B5EF4-FFF2-40B4-BE49-F238E27FC236}">
-                <a16:creationId xmlns:a16="http://schemas.microsoft.com/office/drawing/2014/main" id="{159069A7-9EC8-4D1A-9410-99CCD998F8F8}"/>
+                <a16:creationId xmlns:a16="http://schemas.microsoft.com/office/drawing/2014/main" id="{97AD3ED4-CC7B-4C16-A33F-CB8185D96383}"/>
               </a:ext>
             </a:extLst>
           </p:cNvPr>
@@ -4151,7 +4593,7 @@
     </p:spTree>
     <p:extLst>
       <p:ext uri="{BB962C8B-B14F-4D97-AF65-F5344CB8AC3E}">
-        <p14:creationId xmlns:p14="http://schemas.microsoft.com/office/powerpoint/2010/main" val="1706048970"/>
+        <p14:creationId xmlns:p14="http://schemas.microsoft.com/office/powerpoint/2010/main" val="835250072"/>
       </p:ext>
     </p:extLst>
   </p:cSld>
@@ -4179,10 +4621,10 @@
       </p:grpSpPr>
       <p:sp>
         <p:nvSpPr>
-          <p:cNvPr id="9" name="">
-            <a:extLst xmlns:a="http://schemas.openxmlformats.org/drawingml/2006/main">
-              <a:ext uri="{FF2B5EF4-FFF2-40B4-BE49-F238E27FC236}">
-                <a16:creationId xmlns:a16="http://schemas.microsoft.com/office/drawing/2014/main" id="{BAFB6C4F-7F45-4A4C-B3FD-2CB75B26E111}"/>
+          <p:cNvPr id="11" name="">
+            <a:extLst xmlns:a="http://schemas.openxmlformats.org/drawingml/2006/main">
+              <a:ext uri="{FF2B5EF4-FFF2-40B4-BE49-F238E27FC236}">
+                <a16:creationId xmlns:a16="http://schemas.microsoft.com/office/drawing/2014/main" id="{3FC4F964-E72C-45A9-9540-F9A61D1A323D}"/>
               </a:ext>
             </a:extLst>
           </p:cNvPr>
@@ -4239,7 +4681,7 @@
           <p:cNvPr id="2" name="">
             <a:extLst xmlns:a="http://schemas.openxmlformats.org/drawingml/2006/main">
               <a:ext uri="{FF2B5EF4-FFF2-40B4-BE49-F238E27FC236}">
-                <a16:creationId xmlns:a16="http://schemas.microsoft.com/office/drawing/2014/main" id="{570EA014-CBFD-4C49-8567-7F381316AC57}"/>
+                <a16:creationId xmlns:a16="http://schemas.microsoft.com/office/drawing/2014/main" id="{8DEB6901-EBC1-4B87-9DE4-DB2A2C8CD1F4}"/>
               </a:ext>
             </a:extLst>
           </p:cNvPr>
@@ -4286,7 +4728,7 @@
                 <a:ea typeface="Arial"/>
                 <a:cs typeface="Arial"/>
               </a:rPr>
-              <a:t>PRIMER INGRESO</a:t>
+              <a:t>CONTRATACIÓN</a:t>
             </a:r>
           </a:p>
         </p:txBody>
@@ -4296,7 +4738,7 @@
           <p:cNvPr id="3" name="">
             <a:extLst xmlns:a="http://schemas.openxmlformats.org/drawingml/2006/main">
               <a:ext uri="{FF2B5EF4-FFF2-40B4-BE49-F238E27FC236}">
-                <a16:creationId xmlns:a16="http://schemas.microsoft.com/office/drawing/2014/main" id="{921EFF55-5718-41D2-B26A-1A01EE786719}"/>
+                <a16:creationId xmlns:a16="http://schemas.microsoft.com/office/drawing/2014/main" id="{CC3C0BA6-0144-4E9A-82B4-6893AFEA590F}"/>
               </a:ext>
             </a:extLst>
           </p:cNvPr>
@@ -4343,7 +4785,7 @@
                 <a:ea typeface="Arial"/>
                 <a:cs typeface="Arial"/>
               </a:rPr>
-              <a:t>Qué vas a encontrar</a:t>
+              <a:t>Cómo completar la contratación</a:t>
             </a:r>
           </a:p>
         </p:txBody>
@@ -4353,7 +4795,7 @@
           <p:cNvPr id="4" name="">
             <a:extLst xmlns:a="http://schemas.openxmlformats.org/drawingml/2006/main">
               <a:ext uri="{FF2B5EF4-FFF2-40B4-BE49-F238E27FC236}">
-                <a16:creationId xmlns:a16="http://schemas.microsoft.com/office/drawing/2014/main" id="{7C191CC0-50F7-43F9-B40E-57213BAD698F}"/>
+                <a16:creationId xmlns:a16="http://schemas.microsoft.com/office/drawing/2014/main" id="{0BDC8CF8-E1A2-493F-99D9-BC71E5A4A50C}"/>
               </a:ext>
             </a:extLst>
           </p:cNvPr>
@@ -4400,7 +4842,7 @@
                 <a:ea typeface="Arial"/>
                 <a:cs typeface="Arial"/>
               </a:rPr>
-              <a:t>Después de activar</a:t>
+              <a:t>1. Elegí</a:t>
             </a:r>
           </a:p>
         </p:txBody>
@@ -4410,7 +4852,7 @@
           <p:cNvPr id="5" name="">
             <a:extLst xmlns:a="http://schemas.openxmlformats.org/drawingml/2006/main">
               <a:ext uri="{FF2B5EF4-FFF2-40B4-BE49-F238E27FC236}">
-                <a16:creationId xmlns:a16="http://schemas.microsoft.com/office/drawing/2014/main" id="{884C3255-1B89-40AD-833F-692F2322913C}"/>
+                <a16:creationId xmlns:a16="http://schemas.microsoft.com/office/drawing/2014/main" id="{BB5FD33F-276F-45EB-8F77-4EE53DCB8224}"/>
               </a:ext>
             </a:extLst>
           </p:cNvPr>
@@ -4457,7 +4899,7 @@
                 <a:ea typeface="Arial"/>
                 <a:cs typeface="Arial"/>
               </a:rPr>
-              <a:t>Vas a ver el espacio operativo habilitado para tu plan.</a:t>
+              <a:t>Seleccioná el plan que mejor representa tu operación.</a:t>
             </a:r>
           </a:p>
         </p:txBody>
@@ -4467,7 +4909,7 @@
           <p:cNvPr id="6" name="">
             <a:extLst xmlns:a="http://schemas.openxmlformats.org/drawingml/2006/main">
               <a:ext uri="{FF2B5EF4-FFF2-40B4-BE49-F238E27FC236}">
-                <a16:creationId xmlns:a16="http://schemas.microsoft.com/office/drawing/2014/main" id="{83EED962-D0A0-4649-B851-D896911FD46B}"/>
+                <a16:creationId xmlns:a16="http://schemas.microsoft.com/office/drawing/2014/main" id="{FAFCEDA2-5491-4B61-A081-47AF53009BBE}"/>
               </a:ext>
             </a:extLst>
           </p:cNvPr>
@@ -4514,7 +4956,7 @@
                 <a:ea typeface="Arial"/>
                 <a:cs typeface="Arial"/>
               </a:rPr>
-              <a:t>Antes de activar</a:t>
+              <a:t>2. Autorizá</a:t>
             </a:r>
           </a:p>
         </p:txBody>
@@ -4524,7 +4966,7 @@
           <p:cNvPr id="7" name="">
             <a:extLst xmlns:a="http://schemas.openxmlformats.org/drawingml/2006/main">
               <a:ext uri="{FF2B5EF4-FFF2-40B4-BE49-F238E27FC236}">
-                <a16:creationId xmlns:a16="http://schemas.microsoft.com/office/drawing/2014/main" id="{0A287D15-95BC-4A78-8093-2903E4B05DC7}"/>
+                <a16:creationId xmlns:a16="http://schemas.microsoft.com/office/drawing/2014/main" id="{F4BB5D22-2232-4E96-88EB-5CB755270AA6}"/>
               </a:ext>
             </a:extLst>
           </p:cNvPr>
@@ -4571,7 +5013,7 @@
                 <a:ea typeface="Arial"/>
                 <a:cs typeface="Arial"/>
               </a:rPr>
-              <a:t>La cuenta permanece restringida y conserva la opción de continuar la contratación.</a:t>
+              <a:t>Continuá al flujo seguro de Mercado Pago.</a:t>
             </a:r>
           </a:p>
         </p:txBody>
@@ -4581,7 +5023,121 @@
           <p:cNvPr id="8" name="">
             <a:extLst xmlns:a="http://schemas.openxmlformats.org/drawingml/2006/main">
               <a:ext uri="{FF2B5EF4-FFF2-40B4-BE49-F238E27FC236}">
-                <a16:creationId xmlns:a16="http://schemas.microsoft.com/office/drawing/2014/main" id="{6431BFF4-32BD-49E8-BB3A-97DA6C40E55B}"/>
+                <a16:creationId xmlns:a16="http://schemas.microsoft.com/office/drawing/2014/main" id="{614F6147-69C3-41DD-ABC3-A1878A705AFC}"/>
+              </a:ext>
+            </a:extLst>
+          </p:cNvPr>
+          <p:cNvSpPr>
+            <a:spLocks xmlns:a="http://schemas.openxmlformats.org/drawingml/2006/main" noGrp="1"/>
+          </p:cNvSpPr>
+          <p:nvPr/>
+        </p:nvSpPr>
+        <p:spPr>
+          <a:xfrm xmlns:a="http://schemas.openxmlformats.org/drawingml/2006/main">
+            <a:off x="819150" y="4229100"/>
+            <a:ext cx="3429000" cy="285750"/>
+          </a:xfrm>
+          <a:prstGeom xmlns:a="http://schemas.openxmlformats.org/drawingml/2006/main" prst="rect">
+            <a:avLst/>
+          </a:prstGeom>
+          <a:noFill xmlns:a="http://schemas.openxmlformats.org/drawingml/2006/main"/>
+          <a:ln xmlns:a="http://schemas.openxmlformats.org/drawingml/2006/main" w="0">
+            <a:noFill/>
+          </a:ln>
+        </p:spPr>
+        <p:txBody>
+          <a:bodyPr xmlns:a="http://schemas.openxmlformats.org/drawingml/2006/main">
+            <a:normAutofit fontScale="89474"/>
+          </a:bodyPr>
+          <a:lstStyle xmlns:a="http://schemas.openxmlformats.org/drawingml/2006/main"/>
+          <a:p xmlns:a="http://schemas.openxmlformats.org/drawingml/2006/main">
+            <a:pPr>
+              <a:defRPr sz="1425" b="1">
+                <a:solidFill>
+                  <a:srgbClr val="73C9FF"/>
+                </a:solidFill>
+                <a:latin typeface="Arial"/>
+                <a:ea typeface="Arial"/>
+                <a:cs typeface="Arial"/>
+              </a:defRPr>
+            </a:pPr>
+            <a:r>
+              <a:rPr sz="1425" b="1">
+                <a:solidFill>
+                  <a:srgbClr val="73C9FF"/>
+                </a:solidFill>
+                <a:latin typeface="Arial"/>
+                <a:ea typeface="Arial"/>
+                <a:cs typeface="Arial"/>
+              </a:rPr>
+              <a:t>3. Confirmá</a:t>
+            </a:r>
+          </a:p>
+        </p:txBody>
+      </p:sp>
+      <p:sp>
+        <p:nvSpPr>
+          <p:cNvPr id="9" name="">
+            <a:extLst xmlns:a="http://schemas.openxmlformats.org/drawingml/2006/main">
+              <a:ext uri="{FF2B5EF4-FFF2-40B4-BE49-F238E27FC236}">
+                <a16:creationId xmlns:a16="http://schemas.microsoft.com/office/drawing/2014/main" id="{89EDF7FB-A2AB-4339-8A30-B02B95168550}"/>
+              </a:ext>
+            </a:extLst>
+          </p:cNvPr>
+          <p:cNvSpPr>
+            <a:spLocks xmlns:a="http://schemas.openxmlformats.org/drawingml/2006/main" noGrp="1"/>
+          </p:cNvSpPr>
+          <p:nvPr/>
+        </p:nvSpPr>
+        <p:spPr>
+          <a:xfrm xmlns:a="http://schemas.openxmlformats.org/drawingml/2006/main">
+            <a:off x="4476750" y="4229100"/>
+            <a:ext cx="6667500" cy="533400"/>
+          </a:xfrm>
+          <a:prstGeom xmlns:a="http://schemas.openxmlformats.org/drawingml/2006/main" prst="rect">
+            <a:avLst/>
+          </a:prstGeom>
+          <a:noFill xmlns:a="http://schemas.openxmlformats.org/drawingml/2006/main"/>
+          <a:ln xmlns:a="http://schemas.openxmlformats.org/drawingml/2006/main" w="0">
+            <a:noFill/>
+          </a:ln>
+        </p:spPr>
+        <p:txBody>
+          <a:bodyPr xmlns:a="http://schemas.openxmlformats.org/drawingml/2006/main">
+            <a:normAutofit fontScale="100000"/>
+          </a:bodyPr>
+          <a:lstStyle xmlns:a="http://schemas.openxmlformats.org/drawingml/2006/main"/>
+          <a:p xmlns:a="http://schemas.openxmlformats.org/drawingml/2006/main">
+            <a:pPr>
+              <a:defRPr sz="1425" b="0">
+                <a:solidFill>
+                  <a:srgbClr val="DCE8F6"/>
+                </a:solidFill>
+                <a:latin typeface="Arial"/>
+                <a:ea typeface="Arial"/>
+                <a:cs typeface="Arial"/>
+              </a:defRPr>
+            </a:pPr>
+            <a:r>
+              <a:rPr sz="1425" b="0">
+                <a:solidFill>
+                  <a:srgbClr val="DCE8F6"/>
+                </a:solidFill>
+                <a:latin typeface="Arial"/>
+                <a:ea typeface="Arial"/>
+                <a:cs typeface="Arial"/>
+              </a:rPr>
+              <a:t>El acceso se habilita cuando el pago queda aprobado.</a:t>
+            </a:r>
+          </a:p>
+        </p:txBody>
+      </p:sp>
+      <p:sp>
+        <p:nvSpPr>
+          <p:cNvPr id="10" name="">
+            <a:extLst xmlns:a="http://schemas.openxmlformats.org/drawingml/2006/main">
+              <a:ext uri="{FF2B5EF4-FFF2-40B4-BE49-F238E27FC236}">
+                <a16:creationId xmlns:a16="http://schemas.microsoft.com/office/drawing/2014/main" id="{2A2E332E-0A5A-4A51-B0FA-AE74BEA54221}"/>
               </a:ext>
             </a:extLst>
           </p:cNvPr>
@@ -4636,7 +5192,7 @@
     </p:spTree>
     <p:extLst>
       <p:ext uri="{BB962C8B-B14F-4D97-AF65-F5344CB8AC3E}">
-        <p14:creationId xmlns:p14="http://schemas.microsoft.com/office/powerpoint/2010/main" val="597342408"/>
+        <p14:creationId xmlns:p14="http://schemas.microsoft.com/office/powerpoint/2010/main" val="826860788"/>
       </p:ext>
     </p:extLst>
   </p:cSld>
@@ -4664,10 +5220,10 @@
       </p:grpSpPr>
       <p:sp>
         <p:nvSpPr>
-          <p:cNvPr id="7" name="">
-            <a:extLst xmlns:a="http://schemas.openxmlformats.org/drawingml/2006/main">
-              <a:ext uri="{FF2B5EF4-FFF2-40B4-BE49-F238E27FC236}">
-                <a16:creationId xmlns:a16="http://schemas.microsoft.com/office/drawing/2014/main" id="{B6FA1DCF-9B4F-4912-A2AC-F7AA1B3F6945}"/>
+          <p:cNvPr id="9" name="">
+            <a:extLst xmlns:a="http://schemas.openxmlformats.org/drawingml/2006/main">
+              <a:ext uri="{FF2B5EF4-FFF2-40B4-BE49-F238E27FC236}">
+                <a16:creationId xmlns:a16="http://schemas.microsoft.com/office/drawing/2014/main" id="{C9074B2B-F3EB-4971-B6EB-F323EF453EE1}"/>
               </a:ext>
             </a:extLst>
           </p:cNvPr>
@@ -4724,7 +5280,7 @@
           <p:cNvPr id="2" name="">
             <a:extLst xmlns:a="http://schemas.openxmlformats.org/drawingml/2006/main">
               <a:ext uri="{FF2B5EF4-FFF2-40B4-BE49-F238E27FC236}">
-                <a16:creationId xmlns:a16="http://schemas.microsoft.com/office/drawing/2014/main" id="{626C97FA-955C-42BD-AE7A-944FB7A5A3EA}"/>
+                <a16:creationId xmlns:a16="http://schemas.microsoft.com/office/drawing/2014/main" id="{E19D5B68-5338-4660-9008-34C7A2886FFB}"/>
               </a:ext>
             </a:extLst>
           </p:cNvPr>
@@ -4771,7 +5327,7 @@
                 <a:ea typeface="Arial"/>
                 <a:cs typeface="Arial"/>
               </a:rPr>
-              <a:t>CANALES</a:t>
+              <a:t>PRIMER INGRESO</a:t>
             </a:r>
           </a:p>
         </p:txBody>
@@ -4781,7 +5337,7 @@
           <p:cNvPr id="3" name="">
             <a:extLst xmlns:a="http://schemas.openxmlformats.org/drawingml/2006/main">
               <a:ext uri="{FF2B5EF4-FFF2-40B4-BE49-F238E27FC236}">
-                <a16:creationId xmlns:a16="http://schemas.microsoft.com/office/drawing/2014/main" id="{C1735147-C850-4EF6-A96E-B90179D6BD34}"/>
+                <a16:creationId xmlns:a16="http://schemas.microsoft.com/office/drawing/2014/main" id="{5D02125B-7DA3-475C-B93B-8FA5A4D3B350}"/>
               </a:ext>
             </a:extLst>
           </p:cNvPr>
@@ -4828,7 +5384,7 @@
                 <a:ea typeface="Arial"/>
                 <a:cs typeface="Arial"/>
               </a:rPr>
-              <a:t>Conectar tus canales</a:t>
+              <a:t>Qué vas a encontrar</a:t>
             </a:r>
           </a:p>
         </p:txBody>
@@ -4838,7 +5394,7 @@
           <p:cNvPr id="4" name="">
             <a:extLst xmlns:a="http://schemas.openxmlformats.org/drawingml/2006/main">
               <a:ext uri="{FF2B5EF4-FFF2-40B4-BE49-F238E27FC236}">
-                <a16:creationId xmlns:a16="http://schemas.microsoft.com/office/drawing/2014/main" id="{C8D80C58-83EB-4F05-8D18-20946D5B1462}"/>
+                <a16:creationId xmlns:a16="http://schemas.microsoft.com/office/drawing/2014/main" id="{AB6BD88A-5BF1-429A-86B4-DD36D434B780}"/>
               </a:ext>
             </a:extLst>
           </p:cNvPr>
@@ -4885,7 +5441,7 @@
                 <a:ea typeface="Arial"/>
                 <a:cs typeface="Arial"/>
               </a:rPr>
-              <a:t>WhatsApp e Instagram</a:t>
+              <a:t>Después de activar</a:t>
             </a:r>
           </a:p>
         </p:txBody>
@@ -4895,7 +5451,7 @@
           <p:cNvPr id="5" name="">
             <a:extLst xmlns:a="http://schemas.openxmlformats.org/drawingml/2006/main">
               <a:ext uri="{FF2B5EF4-FFF2-40B4-BE49-F238E27FC236}">
-                <a16:creationId xmlns:a16="http://schemas.microsoft.com/office/drawing/2014/main" id="{76909323-47D4-4A64-8E3C-F84FB9BEA7BA}"/>
+                <a16:creationId xmlns:a16="http://schemas.microsoft.com/office/drawing/2014/main" id="{1A55B849-CCCE-463A-847F-A09F00295304}"/>
               </a:ext>
             </a:extLst>
           </p:cNvPr>
@@ -4942,7 +5498,7 @@
                 <a:ea typeface="Arial"/>
                 <a:cs typeface="Arial"/>
               </a:rPr>
-              <a:t>Conectá los canales disponibles en tu plan y seguí las instrucciones del espacio de integraciones.</a:t>
+              <a:t>Vas a ver el espacio operativo habilitado para tu plan.</a:t>
             </a:r>
           </a:p>
         </p:txBody>
@@ -4952,7 +5508,121 @@
           <p:cNvPr id="6" name="">
             <a:extLst xmlns:a="http://schemas.openxmlformats.org/drawingml/2006/main">
               <a:ext uri="{FF2B5EF4-FFF2-40B4-BE49-F238E27FC236}">
-                <a16:creationId xmlns:a16="http://schemas.microsoft.com/office/drawing/2014/main" id="{1D4DB4A0-F127-4BEF-80C1-EA16D3189824}"/>
+                <a16:creationId xmlns:a16="http://schemas.microsoft.com/office/drawing/2014/main" id="{4E491B0D-C115-4283-930F-967F225CEFEA}"/>
+              </a:ext>
+            </a:extLst>
+          </p:cNvPr>
+          <p:cNvSpPr>
+            <a:spLocks xmlns:a="http://schemas.openxmlformats.org/drawingml/2006/main" noGrp="1"/>
+          </p:cNvSpPr>
+          <p:nvPr/>
+        </p:nvSpPr>
+        <p:spPr>
+          <a:xfrm xmlns:a="http://schemas.openxmlformats.org/drawingml/2006/main">
+            <a:off x="819150" y="3543300"/>
+            <a:ext cx="3429000" cy="285750"/>
+          </a:xfrm>
+          <a:prstGeom xmlns:a="http://schemas.openxmlformats.org/drawingml/2006/main" prst="rect">
+            <a:avLst/>
+          </a:prstGeom>
+          <a:noFill xmlns:a="http://schemas.openxmlformats.org/drawingml/2006/main"/>
+          <a:ln xmlns:a="http://schemas.openxmlformats.org/drawingml/2006/main" w="0">
+            <a:noFill/>
+          </a:ln>
+        </p:spPr>
+        <p:txBody>
+          <a:bodyPr xmlns:a="http://schemas.openxmlformats.org/drawingml/2006/main">
+            <a:normAutofit fontScale="89474"/>
+          </a:bodyPr>
+          <a:lstStyle xmlns:a="http://schemas.openxmlformats.org/drawingml/2006/main"/>
+          <a:p xmlns:a="http://schemas.openxmlformats.org/drawingml/2006/main">
+            <a:pPr>
+              <a:defRPr sz="1425" b="1">
+                <a:solidFill>
+                  <a:srgbClr val="73C9FF"/>
+                </a:solidFill>
+                <a:latin typeface="Arial"/>
+                <a:ea typeface="Arial"/>
+                <a:cs typeface="Arial"/>
+              </a:defRPr>
+            </a:pPr>
+            <a:r>
+              <a:rPr sz="1425" b="1">
+                <a:solidFill>
+                  <a:srgbClr val="73C9FF"/>
+                </a:solidFill>
+                <a:latin typeface="Arial"/>
+                <a:ea typeface="Arial"/>
+                <a:cs typeface="Arial"/>
+              </a:rPr>
+              <a:t>Antes de activar</a:t>
+            </a:r>
+          </a:p>
+        </p:txBody>
+      </p:sp>
+      <p:sp>
+        <p:nvSpPr>
+          <p:cNvPr id="7" name="">
+            <a:extLst xmlns:a="http://schemas.openxmlformats.org/drawingml/2006/main">
+              <a:ext uri="{FF2B5EF4-FFF2-40B4-BE49-F238E27FC236}">
+                <a16:creationId xmlns:a16="http://schemas.microsoft.com/office/drawing/2014/main" id="{C005DDDB-5758-47AD-8731-30F60A8927C1}"/>
+              </a:ext>
+            </a:extLst>
+          </p:cNvPr>
+          <p:cNvSpPr>
+            <a:spLocks xmlns:a="http://schemas.openxmlformats.org/drawingml/2006/main" noGrp="1"/>
+          </p:cNvSpPr>
+          <p:nvPr/>
+        </p:nvSpPr>
+        <p:spPr>
+          <a:xfrm xmlns:a="http://schemas.openxmlformats.org/drawingml/2006/main">
+            <a:off x="4476750" y="3543300"/>
+            <a:ext cx="6667500" cy="533400"/>
+          </a:xfrm>
+          <a:prstGeom xmlns:a="http://schemas.openxmlformats.org/drawingml/2006/main" prst="rect">
+            <a:avLst/>
+          </a:prstGeom>
+          <a:noFill xmlns:a="http://schemas.openxmlformats.org/drawingml/2006/main"/>
+          <a:ln xmlns:a="http://schemas.openxmlformats.org/drawingml/2006/main" w="0">
+            <a:noFill/>
+          </a:ln>
+        </p:spPr>
+        <p:txBody>
+          <a:bodyPr xmlns:a="http://schemas.openxmlformats.org/drawingml/2006/main">
+            <a:normAutofit fontScale="100000"/>
+          </a:bodyPr>
+          <a:lstStyle xmlns:a="http://schemas.openxmlformats.org/drawingml/2006/main"/>
+          <a:p xmlns:a="http://schemas.openxmlformats.org/drawingml/2006/main">
+            <a:pPr>
+              <a:defRPr sz="1425" b="0">
+                <a:solidFill>
+                  <a:srgbClr val="DCE8F6"/>
+                </a:solidFill>
+                <a:latin typeface="Arial"/>
+                <a:ea typeface="Arial"/>
+                <a:cs typeface="Arial"/>
+              </a:defRPr>
+            </a:pPr>
+            <a:r>
+              <a:rPr sz="1425" b="0">
+                <a:solidFill>
+                  <a:srgbClr val="DCE8F6"/>
+                </a:solidFill>
+                <a:latin typeface="Arial"/>
+                <a:ea typeface="Arial"/>
+                <a:cs typeface="Arial"/>
+              </a:rPr>
+              <a:t>La cuenta permanece restringida y conserva la opción de continuar la contratación.</a:t>
+            </a:r>
+          </a:p>
+        </p:txBody>
+      </p:sp>
+      <p:sp>
+        <p:nvSpPr>
+          <p:cNvPr id="8" name="">
+            <a:extLst xmlns:a="http://schemas.openxmlformats.org/drawingml/2006/main">
+              <a:ext uri="{FF2B5EF4-FFF2-40B4-BE49-F238E27FC236}">
+                <a16:creationId xmlns:a16="http://schemas.microsoft.com/office/drawing/2014/main" id="{0DAB7452-8A90-4B76-BF22-193AC4CFD383}"/>
               </a:ext>
             </a:extLst>
           </p:cNvPr>
@@ -5007,7 +5677,7 @@
     </p:spTree>
     <p:extLst>
       <p:ext uri="{BB962C8B-B14F-4D97-AF65-F5344CB8AC3E}">
-        <p14:creationId xmlns:p14="http://schemas.microsoft.com/office/powerpoint/2010/main" val="715494360"/>
+        <p14:creationId xmlns:p14="http://schemas.microsoft.com/office/powerpoint/2010/main" val="1082731135"/>
       </p:ext>
     </p:extLst>
   </p:cSld>
@@ -5035,10 +5705,10 @@
       </p:grpSpPr>
       <p:sp>
         <p:nvSpPr>
-          <p:cNvPr id="9" name="">
-            <a:extLst xmlns:a="http://schemas.openxmlformats.org/drawingml/2006/main">
-              <a:ext uri="{FF2B5EF4-FFF2-40B4-BE49-F238E27FC236}">
-                <a16:creationId xmlns:a16="http://schemas.microsoft.com/office/drawing/2014/main" id="{498A5A4A-8FE6-4F03-AD3C-1F9281648DB2}"/>
+          <p:cNvPr id="7" name="">
+            <a:extLst xmlns:a="http://schemas.openxmlformats.org/drawingml/2006/main">
+              <a:ext uri="{FF2B5EF4-FFF2-40B4-BE49-F238E27FC236}">
+                <a16:creationId xmlns:a16="http://schemas.microsoft.com/office/drawing/2014/main" id="{99B22DBE-4F9B-4817-9232-303ADD0BB31A}"/>
               </a:ext>
             </a:extLst>
           </p:cNvPr>
@@ -5095,7 +5765,7 @@
           <p:cNvPr id="2" name="">
             <a:extLst xmlns:a="http://schemas.openxmlformats.org/drawingml/2006/main">
               <a:ext uri="{FF2B5EF4-FFF2-40B4-BE49-F238E27FC236}">
-                <a16:creationId xmlns:a16="http://schemas.microsoft.com/office/drawing/2014/main" id="{C1006BF8-0D3C-45BA-B6C1-C85F178DD908}"/>
+                <a16:creationId xmlns:a16="http://schemas.microsoft.com/office/drawing/2014/main" id="{957A8A64-813F-4E4E-B6C3-AC85AEE7CABF}"/>
               </a:ext>
             </a:extLst>
           </p:cNvPr>
@@ -5142,7 +5812,7 @@
                 <a:ea typeface="Arial"/>
                 <a:cs typeface="Arial"/>
               </a:rPr>
-              <a:t>CONFIGURACIÓN</a:t>
+              <a:t>CANALES</a:t>
             </a:r>
           </a:p>
         </p:txBody>
@@ -5152,7 +5822,7 @@
           <p:cNvPr id="3" name="">
             <a:extLst xmlns:a="http://schemas.openxmlformats.org/drawingml/2006/main">
               <a:ext uri="{FF2B5EF4-FFF2-40B4-BE49-F238E27FC236}">
-                <a16:creationId xmlns:a16="http://schemas.microsoft.com/office/drawing/2014/main" id="{8ECC76CE-E942-4CFC-8230-56D808CB1296}"/>
+                <a16:creationId xmlns:a16="http://schemas.microsoft.com/office/drawing/2014/main" id="{15EB691C-FA5E-4591-A88C-70005390F0E5}"/>
               </a:ext>
             </a:extLst>
           </p:cNvPr>
@@ -5199,7 +5869,7 @@
                 <a:ea typeface="Arial"/>
                 <a:cs typeface="Arial"/>
               </a:rPr>
-              <a:t>Cargar productos y datos</a:t>
+              <a:t>Conectar tus canales</a:t>
             </a:r>
           </a:p>
         </p:txBody>
@@ -5209,7 +5879,7 @@
           <p:cNvPr id="4" name="">
             <a:extLst xmlns:a="http://schemas.openxmlformats.org/drawingml/2006/main">
               <a:ext uri="{FF2B5EF4-FFF2-40B4-BE49-F238E27FC236}">
-                <a16:creationId xmlns:a16="http://schemas.microsoft.com/office/drawing/2014/main" id="{34309B1F-9F98-4988-A1B2-9CCA940D13CD}"/>
+                <a16:creationId xmlns:a16="http://schemas.microsoft.com/office/drawing/2014/main" id="{CC145C37-A16C-4075-ABA9-70FC71B69666}"/>
               </a:ext>
             </a:extLst>
           </p:cNvPr>
@@ -5256,7 +5926,7 @@
                 <a:ea typeface="Arial"/>
                 <a:cs typeface="Arial"/>
               </a:rPr>
-              <a:t>Base inicial</a:t>
+              <a:t>WhatsApp e Instagram</a:t>
             </a:r>
           </a:p>
         </p:txBody>
@@ -5266,7 +5936,7 @@
           <p:cNvPr id="5" name="">
             <a:extLst xmlns:a="http://schemas.openxmlformats.org/drawingml/2006/main">
               <a:ext uri="{FF2B5EF4-FFF2-40B4-BE49-F238E27FC236}">
-                <a16:creationId xmlns:a16="http://schemas.microsoft.com/office/drawing/2014/main" id="{CAFE9F9B-88FA-4FC2-B7B1-B18EB332F81C}"/>
+                <a16:creationId xmlns:a16="http://schemas.microsoft.com/office/drawing/2014/main" id="{05E5579C-2C77-4019-BA5A-F1CD6E9D6191}"/>
               </a:ext>
             </a:extLst>
           </p:cNvPr>
@@ -5313,7 +5983,7 @@
                 <a:ea typeface="Arial"/>
                 <a:cs typeface="Arial"/>
               </a:rPr>
-              <a:t>Comenzá con productos, contactos y la información que tu equipo usa a diario.</a:t>
+              <a:t>Conectá los canales disponibles en tu plan y seguí las instrucciones del espacio de integraciones.</a:t>
             </a:r>
           </a:p>
         </p:txBody>
@@ -5323,121 +5993,7 @@
           <p:cNvPr id="6" name="">
             <a:extLst xmlns:a="http://schemas.openxmlformats.org/drawingml/2006/main">
               <a:ext uri="{FF2B5EF4-FFF2-40B4-BE49-F238E27FC236}">
-                <a16:creationId xmlns:a16="http://schemas.microsoft.com/office/drawing/2014/main" id="{A3E2AD3E-2D25-4C31-81F2-981A64FDE112}"/>
-              </a:ext>
-            </a:extLst>
-          </p:cNvPr>
-          <p:cNvSpPr>
-            <a:spLocks xmlns:a="http://schemas.openxmlformats.org/drawingml/2006/main" noGrp="1"/>
-          </p:cNvSpPr>
-          <p:nvPr/>
-        </p:nvSpPr>
-        <p:spPr>
-          <a:xfrm xmlns:a="http://schemas.openxmlformats.org/drawingml/2006/main">
-            <a:off x="819150" y="3543300"/>
-            <a:ext cx="3429000" cy="285750"/>
-          </a:xfrm>
-          <a:prstGeom xmlns:a="http://schemas.openxmlformats.org/drawingml/2006/main" prst="rect">
-            <a:avLst/>
-          </a:prstGeom>
-          <a:noFill xmlns:a="http://schemas.openxmlformats.org/drawingml/2006/main"/>
-          <a:ln xmlns:a="http://schemas.openxmlformats.org/drawingml/2006/main" w="0">
-            <a:noFill/>
-          </a:ln>
-        </p:spPr>
-        <p:txBody>
-          <a:bodyPr xmlns:a="http://schemas.openxmlformats.org/drawingml/2006/main">
-            <a:normAutofit fontScale="89474"/>
-          </a:bodyPr>
-          <a:lstStyle xmlns:a="http://schemas.openxmlformats.org/drawingml/2006/main"/>
-          <a:p xmlns:a="http://schemas.openxmlformats.org/drawingml/2006/main">
-            <a:pPr>
-              <a:defRPr sz="1425" b="1">
-                <a:solidFill>
-                  <a:srgbClr val="73C9FF"/>
-                </a:solidFill>
-                <a:latin typeface="Arial"/>
-                <a:ea typeface="Arial"/>
-                <a:cs typeface="Arial"/>
-              </a:defRPr>
-            </a:pPr>
-            <a:r>
-              <a:rPr sz="1425" b="1">
-                <a:solidFill>
-                  <a:srgbClr val="73C9FF"/>
-                </a:solidFill>
-                <a:latin typeface="Arial"/>
-                <a:ea typeface="Arial"/>
-                <a:cs typeface="Arial"/>
-              </a:rPr>
-              <a:t>Paso gradual</a:t>
-            </a:r>
-          </a:p>
-        </p:txBody>
-      </p:sp>
-      <p:sp>
-        <p:nvSpPr>
-          <p:cNvPr id="7" name="">
-            <a:extLst xmlns:a="http://schemas.openxmlformats.org/drawingml/2006/main">
-              <a:ext uri="{FF2B5EF4-FFF2-40B4-BE49-F238E27FC236}">
-                <a16:creationId xmlns:a16="http://schemas.microsoft.com/office/drawing/2014/main" id="{D186A386-5615-4E24-B8E7-6C889C32A909}"/>
-              </a:ext>
-            </a:extLst>
-          </p:cNvPr>
-          <p:cNvSpPr>
-            <a:spLocks xmlns:a="http://schemas.openxmlformats.org/drawingml/2006/main" noGrp="1"/>
-          </p:cNvSpPr>
-          <p:nvPr/>
-        </p:nvSpPr>
-        <p:spPr>
-          <a:xfrm xmlns:a="http://schemas.openxmlformats.org/drawingml/2006/main">
-            <a:off x="4476750" y="3543300"/>
-            <a:ext cx="6667500" cy="533400"/>
-          </a:xfrm>
-          <a:prstGeom xmlns:a="http://schemas.openxmlformats.org/drawingml/2006/main" prst="rect">
-            <a:avLst/>
-          </a:prstGeom>
-          <a:noFill xmlns:a="http://schemas.openxmlformats.org/drawingml/2006/main"/>
-          <a:ln xmlns:a="http://schemas.openxmlformats.org/drawingml/2006/main" w="0">
-            <a:noFill/>
-          </a:ln>
-        </p:spPr>
-        <p:txBody>
-          <a:bodyPr xmlns:a="http://schemas.openxmlformats.org/drawingml/2006/main">
-            <a:normAutofit fontScale="100000"/>
-          </a:bodyPr>
-          <a:lstStyle xmlns:a="http://schemas.openxmlformats.org/drawingml/2006/main"/>
-          <a:p xmlns:a="http://schemas.openxmlformats.org/drawingml/2006/main">
-            <a:pPr>
-              <a:defRPr sz="1425" b="0">
-                <a:solidFill>
-                  <a:srgbClr val="DCE8F6"/>
-                </a:solidFill>
-                <a:latin typeface="Arial"/>
-                <a:ea typeface="Arial"/>
-                <a:cs typeface="Arial"/>
-              </a:defRPr>
-            </a:pPr>
-            <a:r>
-              <a:rPr sz="1425" b="0">
-                <a:solidFill>
-                  <a:srgbClr val="DCE8F6"/>
-                </a:solidFill>
-                <a:latin typeface="Arial"/>
-                <a:ea typeface="Arial"/>
-                <a:cs typeface="Arial"/>
-              </a:rPr>
-              <a:t>Podés completar la configuración por etapas, según tu operación.</a:t>
-            </a:r>
-          </a:p>
-        </p:txBody>
-      </p:sp>
-      <p:sp>
-        <p:nvSpPr>
-          <p:cNvPr id="8" name="">
-            <a:extLst xmlns:a="http://schemas.openxmlformats.org/drawingml/2006/main">
-              <a:ext uri="{FF2B5EF4-FFF2-40B4-BE49-F238E27FC236}">
-                <a16:creationId xmlns:a16="http://schemas.microsoft.com/office/drawing/2014/main" id="{FD90F549-533F-41CC-83C4-9594DCC5304E}"/>
+                <a16:creationId xmlns:a16="http://schemas.microsoft.com/office/drawing/2014/main" id="{890DE2FB-948A-4C69-B139-E976034D4EBF}"/>
               </a:ext>
             </a:extLst>
           </p:cNvPr>
@@ -5492,7 +6048,7 @@
     </p:spTree>
     <p:extLst>
       <p:ext uri="{BB962C8B-B14F-4D97-AF65-F5344CB8AC3E}">
-        <p14:creationId xmlns:p14="http://schemas.microsoft.com/office/powerpoint/2010/main" val="2115997421"/>
+        <p14:creationId xmlns:p14="http://schemas.microsoft.com/office/powerpoint/2010/main" val="1548815706"/>
       </p:ext>
     </p:extLst>
   </p:cSld>
@@ -5523,7 +6079,7 @@
           <p:cNvPr id="9" name="">
             <a:extLst xmlns:a="http://schemas.openxmlformats.org/drawingml/2006/main">
               <a:ext uri="{FF2B5EF4-FFF2-40B4-BE49-F238E27FC236}">
-                <a16:creationId xmlns:a16="http://schemas.microsoft.com/office/drawing/2014/main" id="{84185426-F704-4641-A8F4-5148F2B03922}"/>
+                <a16:creationId xmlns:a16="http://schemas.microsoft.com/office/drawing/2014/main" id="{0C5A41F8-DA3F-40B7-ADC4-10680C77BB73}"/>
               </a:ext>
             </a:extLst>
           </p:cNvPr>
@@ -5580,7 +6136,7 @@
           <p:cNvPr id="2" name="">
             <a:extLst xmlns:a="http://schemas.openxmlformats.org/drawingml/2006/main">
               <a:ext uri="{FF2B5EF4-FFF2-40B4-BE49-F238E27FC236}">
-                <a16:creationId xmlns:a16="http://schemas.microsoft.com/office/drawing/2014/main" id="{24A0B71B-5354-43D5-9512-44936678FE3C}"/>
+                <a16:creationId xmlns:a16="http://schemas.microsoft.com/office/drawing/2014/main" id="{4F94695B-9EE9-47B0-B09D-EE428F7F1819}"/>
               </a:ext>
             </a:extLst>
           </p:cNvPr>
@@ -5627,7 +6183,7 @@
                 <a:ea typeface="Arial"/>
                 <a:cs typeface="Arial"/>
               </a:rPr>
-              <a:t>OPERACIÓN</a:t>
+              <a:t>CONFIGURACIÓN</a:t>
             </a:r>
           </a:p>
         </p:txBody>
@@ -5637,7 +6193,7 @@
           <p:cNvPr id="3" name="">
             <a:extLst xmlns:a="http://schemas.openxmlformats.org/drawingml/2006/main">
               <a:ext uri="{FF2B5EF4-FFF2-40B4-BE49-F238E27FC236}">
-                <a16:creationId xmlns:a16="http://schemas.microsoft.com/office/drawing/2014/main" id="{EE152950-921A-48E0-A23D-B4F712D72787}"/>
+                <a16:creationId xmlns:a16="http://schemas.microsoft.com/office/drawing/2014/main" id="{43DF185C-A668-4929-B4B4-D54D9127FDAC}"/>
               </a:ext>
             </a:extLst>
           </p:cNvPr>
@@ -5684,7 +6240,7 @@
                 <a:ea typeface="Arial"/>
                 <a:cs typeface="Arial"/>
               </a:rPr>
-              <a:t>Inbox, CRM y pipeline</a:t>
+              <a:t>Cargar productos y datos</a:t>
             </a:r>
           </a:p>
         </p:txBody>
@@ -5694,7 +6250,7 @@
           <p:cNvPr id="4" name="">
             <a:extLst xmlns:a="http://schemas.openxmlformats.org/drawingml/2006/main">
               <a:ext uri="{FF2B5EF4-FFF2-40B4-BE49-F238E27FC236}">
-                <a16:creationId xmlns:a16="http://schemas.microsoft.com/office/drawing/2014/main" id="{2DB910CE-30D8-4A61-8D72-AF88A22331F1}"/>
+                <a16:creationId xmlns:a16="http://schemas.microsoft.com/office/drawing/2014/main" id="{3C03D128-B8BB-4121-97D5-F8BC297E65BD}"/>
               </a:ext>
             </a:extLst>
           </p:cNvPr>
@@ -5741,7 +6297,7 @@
                 <a:ea typeface="Arial"/>
                 <a:cs typeface="Arial"/>
               </a:rPr>
-              <a:t>Conversaciones</a:t>
+              <a:t>Base inicial</a:t>
             </a:r>
           </a:p>
         </p:txBody>
@@ -5751,7 +6307,7 @@
           <p:cNvPr id="5" name="">
             <a:extLst xmlns:a="http://schemas.openxmlformats.org/drawingml/2006/main">
               <a:ext uri="{FF2B5EF4-FFF2-40B4-BE49-F238E27FC236}">
-                <a16:creationId xmlns:a16="http://schemas.microsoft.com/office/drawing/2014/main" id="{76DC1BFB-F338-4601-81EE-36FB51B9A985}"/>
+                <a16:creationId xmlns:a16="http://schemas.microsoft.com/office/drawing/2014/main" id="{3CE0A908-C3FF-4C44-BCB1-1A1D9A3C0AF3}"/>
               </a:ext>
             </a:extLst>
           </p:cNvPr>
@@ -5798,7 +6354,7 @@
                 <a:ea typeface="Arial"/>
                 <a:cs typeface="Arial"/>
               </a:rPr>
-              <a:t>Centralizá consultas y seguimientos para que ninguna oportunidad quede sin contexto.</a:t>
+              <a:t>Comenzá con productos, contactos y la información que tu equipo usa a diario.</a:t>
             </a:r>
           </a:p>
         </p:txBody>
@@ -5808,7 +6364,7 @@
           <p:cNvPr id="6" name="">
             <a:extLst xmlns:a="http://schemas.openxmlformats.org/drawingml/2006/main">
               <a:ext uri="{FF2B5EF4-FFF2-40B4-BE49-F238E27FC236}">
-                <a16:creationId xmlns:a16="http://schemas.microsoft.com/office/drawing/2014/main" id="{90DE69ED-D7CC-478A-BA35-71FC222386CA}"/>
+                <a16:creationId xmlns:a16="http://schemas.microsoft.com/office/drawing/2014/main" id="{61FD2244-4551-4A38-81DE-442BCB267D76}"/>
               </a:ext>
             </a:extLst>
           </p:cNvPr>
@@ -5855,7 +6411,7 @@
                 <a:ea typeface="Arial"/>
                 <a:cs typeface="Arial"/>
               </a:rPr>
-              <a:t>Clientes</a:t>
+              <a:t>Paso gradual</a:t>
             </a:r>
           </a:p>
         </p:txBody>
@@ -5865,7 +6421,7 @@
           <p:cNvPr id="7" name="">
             <a:extLst xmlns:a="http://schemas.openxmlformats.org/drawingml/2006/main">
               <a:ext uri="{FF2B5EF4-FFF2-40B4-BE49-F238E27FC236}">
-                <a16:creationId xmlns:a16="http://schemas.microsoft.com/office/drawing/2014/main" id="{9F8BEF64-DBEB-4358-A381-B82DB0417780}"/>
+                <a16:creationId xmlns:a16="http://schemas.microsoft.com/office/drawing/2014/main" id="{0333329A-6956-4AFC-A0F8-7C9386ADC10E}"/>
               </a:ext>
             </a:extLst>
           </p:cNvPr>
@@ -5912,7 +6468,7 @@
                 <a:ea typeface="Arial"/>
                 <a:cs typeface="Arial"/>
               </a:rPr>
-              <a:t>Ordená contactos y etapas comerciales desde un mismo lugar.</a:t>
+              <a:t>Podés completar la configuración por etapas, según tu operación.</a:t>
             </a:r>
           </a:p>
         </p:txBody>
@@ -5922,7 +6478,7 @@
           <p:cNvPr id="8" name="">
             <a:extLst xmlns:a="http://schemas.openxmlformats.org/drawingml/2006/main">
               <a:ext uri="{FF2B5EF4-FFF2-40B4-BE49-F238E27FC236}">
-                <a16:creationId xmlns:a16="http://schemas.microsoft.com/office/drawing/2014/main" id="{7C9ACAE8-3823-4169-90C3-B1CDFD039F03}"/>
+                <a16:creationId xmlns:a16="http://schemas.microsoft.com/office/drawing/2014/main" id="{4B4E9B0D-2698-4DA3-88F9-CE0DBB20CB8D}"/>
               </a:ext>
             </a:extLst>
           </p:cNvPr>
@@ -5977,7 +6533,7 @@
     </p:spTree>
     <p:extLst>
       <p:ext uri="{BB962C8B-B14F-4D97-AF65-F5344CB8AC3E}">
-        <p14:creationId xmlns:p14="http://schemas.microsoft.com/office/powerpoint/2010/main" val="1851821940"/>
+        <p14:creationId xmlns:p14="http://schemas.microsoft.com/office/powerpoint/2010/main" val="553300600"/>
       </p:ext>
     </p:extLst>
   </p:cSld>
@@ -6005,10 +6561,10 @@
       </p:grpSpPr>
       <p:sp>
         <p:nvSpPr>
-          <p:cNvPr id="7" name="">
-            <a:extLst xmlns:a="http://schemas.openxmlformats.org/drawingml/2006/main">
-              <a:ext uri="{FF2B5EF4-FFF2-40B4-BE49-F238E27FC236}">
-                <a16:creationId xmlns:a16="http://schemas.microsoft.com/office/drawing/2014/main" id="{CE851082-6AA1-4B12-82B1-BC0F56D328B4}"/>
+          <p:cNvPr id="9" name="">
+            <a:extLst xmlns:a="http://schemas.openxmlformats.org/drawingml/2006/main">
+              <a:ext uri="{FF2B5EF4-FFF2-40B4-BE49-F238E27FC236}">
+                <a16:creationId xmlns:a16="http://schemas.microsoft.com/office/drawing/2014/main" id="{A5C9666B-09D8-42D3-9604-ED9BB1CA6E1F}"/>
               </a:ext>
             </a:extLst>
           </p:cNvPr>
@@ -6065,7 +6621,7 @@
           <p:cNvPr id="2" name="">
             <a:extLst xmlns:a="http://schemas.openxmlformats.org/drawingml/2006/main">
               <a:ext uri="{FF2B5EF4-FFF2-40B4-BE49-F238E27FC236}">
-                <a16:creationId xmlns:a16="http://schemas.microsoft.com/office/drawing/2014/main" id="{0E27F3CB-8418-4540-A0ED-16A66063247E}"/>
+                <a16:creationId xmlns:a16="http://schemas.microsoft.com/office/drawing/2014/main" id="{538FCF49-8961-4F1E-B173-BDED7C156739}"/>
               </a:ext>
             </a:extLst>
           </p:cNvPr>
@@ -6112,7 +6668,7 @@
                 <a:ea typeface="Arial"/>
                 <a:cs typeface="Arial"/>
               </a:rPr>
-              <a:t>AUTOMATIZACIÓN</a:t>
+              <a:t>OPERACIÓN</a:t>
             </a:r>
           </a:p>
         </p:txBody>
@@ -6122,7 +6678,7 @@
           <p:cNvPr id="3" name="">
             <a:extLst xmlns:a="http://schemas.openxmlformats.org/drawingml/2006/main">
               <a:ext uri="{FF2B5EF4-FFF2-40B4-BE49-F238E27FC236}">
-                <a16:creationId xmlns:a16="http://schemas.microsoft.com/office/drawing/2014/main" id="{7BDF69B9-5770-4E4F-ACEB-08FF23E5C895}"/>
+                <a16:creationId xmlns:a16="http://schemas.microsoft.com/office/drawing/2014/main" id="{BDCC60DB-3A7D-476E-BFD3-3AA61131B722}"/>
               </a:ext>
             </a:extLst>
           </p:cNvPr>
@@ -6169,7 +6725,7 @@
                 <a:ea typeface="Arial"/>
                 <a:cs typeface="Arial"/>
               </a:rPr>
-              <a:t>Automatizaciones y asistente</a:t>
+              <a:t>Inbox, CRM y pipeline</a:t>
             </a:r>
           </a:p>
         </p:txBody>
@@ -6179,7 +6735,7 @@
           <p:cNvPr id="4" name="">
             <a:extLst xmlns:a="http://schemas.openxmlformats.org/drawingml/2006/main">
               <a:ext uri="{FF2B5EF4-FFF2-40B4-BE49-F238E27FC236}">
-                <a16:creationId xmlns:a16="http://schemas.microsoft.com/office/drawing/2014/main" id="{F853734F-7101-4193-9446-5598BBB9D86F}"/>
+                <a16:creationId xmlns:a16="http://schemas.microsoft.com/office/drawing/2014/main" id="{C3644F37-A876-4E10-87F3-E142756237A7}"/>
               </a:ext>
             </a:extLst>
           </p:cNvPr>
@@ -6226,7 +6782,7 @@
                 <a:ea typeface="Arial"/>
                 <a:cs typeface="Arial"/>
               </a:rPr>
-              <a:t>Capacidades</a:t>
+              <a:t>Conversaciones</a:t>
             </a:r>
           </a:p>
         </p:txBody>
@@ -6236,7 +6792,7 @@
           <p:cNvPr id="5" name="">
             <a:extLst xmlns:a="http://schemas.openxmlformats.org/drawingml/2006/main">
               <a:ext uri="{FF2B5EF4-FFF2-40B4-BE49-F238E27FC236}">
-                <a16:creationId xmlns:a16="http://schemas.microsoft.com/office/drawing/2014/main" id="{359AF827-1F7E-40A9-A423-9EF8AD5AD0EC}"/>
+                <a16:creationId xmlns:a16="http://schemas.microsoft.com/office/drawing/2014/main" id="{95F03B6C-18E5-46C8-8A25-846A8FD2ACA4}"/>
               </a:ext>
             </a:extLst>
           </p:cNvPr>
@@ -6283,7 +6839,7 @@
                 <a:ea typeface="Arial"/>
                 <a:cs typeface="Arial"/>
               </a:rPr>
-              <a:t>Las automatizaciones y el asistente disponibles dependen del plan contratado.</a:t>
+              <a:t>Centralizá consultas y seguimientos para que ninguna oportunidad quede sin contexto.</a:t>
             </a:r>
           </a:p>
         </p:txBody>
@@ -6293,7 +6849,121 @@
           <p:cNvPr id="6" name="">
             <a:extLst xmlns:a="http://schemas.openxmlformats.org/drawingml/2006/main">
               <a:ext uri="{FF2B5EF4-FFF2-40B4-BE49-F238E27FC236}">
-                <a16:creationId xmlns:a16="http://schemas.microsoft.com/office/drawing/2014/main" id="{633B746B-4A73-4D10-8513-8DC6BFEDCEE1}"/>
+                <a16:creationId xmlns:a16="http://schemas.microsoft.com/office/drawing/2014/main" id="{2246E4C1-1AA1-4DB9-9523-C4C3F320216E}"/>
+              </a:ext>
+            </a:extLst>
+          </p:cNvPr>
+          <p:cNvSpPr>
+            <a:spLocks xmlns:a="http://schemas.openxmlformats.org/drawingml/2006/main" noGrp="1"/>
+          </p:cNvSpPr>
+          <p:nvPr/>
+        </p:nvSpPr>
+        <p:spPr>
+          <a:xfrm xmlns:a="http://schemas.openxmlformats.org/drawingml/2006/main">
+            <a:off x="819150" y="3543300"/>
+            <a:ext cx="3429000" cy="285750"/>
+          </a:xfrm>
+          <a:prstGeom xmlns:a="http://schemas.openxmlformats.org/drawingml/2006/main" prst="rect">
+            <a:avLst/>
+          </a:prstGeom>
+          <a:noFill xmlns:a="http://schemas.openxmlformats.org/drawingml/2006/main"/>
+          <a:ln xmlns:a="http://schemas.openxmlformats.org/drawingml/2006/main" w="0">
+            <a:noFill/>
+          </a:ln>
+        </p:spPr>
+        <p:txBody>
+          <a:bodyPr xmlns:a="http://schemas.openxmlformats.org/drawingml/2006/main">
+            <a:normAutofit fontScale="89474"/>
+          </a:bodyPr>
+          <a:lstStyle xmlns:a="http://schemas.openxmlformats.org/drawingml/2006/main"/>
+          <a:p xmlns:a="http://schemas.openxmlformats.org/drawingml/2006/main">
+            <a:pPr>
+              <a:defRPr sz="1425" b="1">
+                <a:solidFill>
+                  <a:srgbClr val="73C9FF"/>
+                </a:solidFill>
+                <a:latin typeface="Arial"/>
+                <a:ea typeface="Arial"/>
+                <a:cs typeface="Arial"/>
+              </a:defRPr>
+            </a:pPr>
+            <a:r>
+              <a:rPr sz="1425" b="1">
+                <a:solidFill>
+                  <a:srgbClr val="73C9FF"/>
+                </a:solidFill>
+                <a:latin typeface="Arial"/>
+                <a:ea typeface="Arial"/>
+                <a:cs typeface="Arial"/>
+              </a:rPr>
+              <a:t>Clientes</a:t>
+            </a:r>
+          </a:p>
+        </p:txBody>
+      </p:sp>
+      <p:sp>
+        <p:nvSpPr>
+          <p:cNvPr id="7" name="">
+            <a:extLst xmlns:a="http://schemas.openxmlformats.org/drawingml/2006/main">
+              <a:ext uri="{FF2B5EF4-FFF2-40B4-BE49-F238E27FC236}">
+                <a16:creationId xmlns:a16="http://schemas.microsoft.com/office/drawing/2014/main" id="{65B4397E-282C-4670-A7FD-8B7B97083950}"/>
+              </a:ext>
+            </a:extLst>
+          </p:cNvPr>
+          <p:cNvSpPr>
+            <a:spLocks xmlns:a="http://schemas.openxmlformats.org/drawingml/2006/main" noGrp="1"/>
+          </p:cNvSpPr>
+          <p:nvPr/>
+        </p:nvSpPr>
+        <p:spPr>
+          <a:xfrm xmlns:a="http://schemas.openxmlformats.org/drawingml/2006/main">
+            <a:off x="4476750" y="3543300"/>
+            <a:ext cx="6667500" cy="533400"/>
+          </a:xfrm>
+          <a:prstGeom xmlns:a="http://schemas.openxmlformats.org/drawingml/2006/main" prst="rect">
+            <a:avLst/>
+          </a:prstGeom>
+          <a:noFill xmlns:a="http://schemas.openxmlformats.org/drawingml/2006/main"/>
+          <a:ln xmlns:a="http://schemas.openxmlformats.org/drawingml/2006/main" w="0">
+            <a:noFill/>
+          </a:ln>
+        </p:spPr>
+        <p:txBody>
+          <a:bodyPr xmlns:a="http://schemas.openxmlformats.org/drawingml/2006/main">
+            <a:normAutofit fontScale="100000"/>
+          </a:bodyPr>
+          <a:lstStyle xmlns:a="http://schemas.openxmlformats.org/drawingml/2006/main"/>
+          <a:p xmlns:a="http://schemas.openxmlformats.org/drawingml/2006/main">
+            <a:pPr>
+              <a:defRPr sz="1425" b="0">
+                <a:solidFill>
+                  <a:srgbClr val="DCE8F6"/>
+                </a:solidFill>
+                <a:latin typeface="Arial"/>
+                <a:ea typeface="Arial"/>
+                <a:cs typeface="Arial"/>
+              </a:defRPr>
+            </a:pPr>
+            <a:r>
+              <a:rPr sz="1425" b="0">
+                <a:solidFill>
+                  <a:srgbClr val="DCE8F6"/>
+                </a:solidFill>
+                <a:latin typeface="Arial"/>
+                <a:ea typeface="Arial"/>
+                <a:cs typeface="Arial"/>
+              </a:rPr>
+              <a:t>Ordená contactos y etapas comerciales desde un mismo lugar.</a:t>
+            </a:r>
+          </a:p>
+        </p:txBody>
+      </p:sp>
+      <p:sp>
+        <p:nvSpPr>
+          <p:cNvPr id="8" name="">
+            <a:extLst xmlns:a="http://schemas.openxmlformats.org/drawingml/2006/main">
+              <a:ext uri="{FF2B5EF4-FFF2-40B4-BE49-F238E27FC236}">
+                <a16:creationId xmlns:a16="http://schemas.microsoft.com/office/drawing/2014/main" id="{55AD42CC-EBDF-443C-8853-2293D427A691}"/>
               </a:ext>
             </a:extLst>
           </p:cNvPr>
@@ -6348,7 +7018,7 @@
     </p:spTree>
     <p:extLst>
       <p:ext uri="{BB962C8B-B14F-4D97-AF65-F5344CB8AC3E}">
-        <p14:creationId xmlns:p14="http://schemas.microsoft.com/office/powerpoint/2010/main" val="1890995904"/>
+        <p14:creationId xmlns:p14="http://schemas.microsoft.com/office/powerpoint/2010/main" val="883984527"/>
       </p:ext>
     </p:extLst>
   </p:cSld>

</xml_diff>